<commit_message>
fix(docs): make showcase deck reproducible
</commit_message>
<xml_diff>
--- a/artifacts/showcase/yeaft-editorial-minimal.pptx
+++ b/artifacts/showcase/yeaft-editorial-minimal.pptx
@@ -2216,7 +2216,7 @@
       </p:sp>
       <p:pic>
         <p:nvPicPr>
-          <p:cNvPr id="7" name="Image 0" descr="/home/azureuser/projects/yeaft-web-code-agent/.yeaft/worktrees/showcase-editorial-ppt/artifacts/showcase/assets/01-home.png">    </p:cNvPr>
+          <p:cNvPr id="7" name="Image 0" descr="/home/azureuser/projects/yeaft-web-code-agent/.yeaft/worktrees/fix-pr-1669-review-blockers/artifacts/showcase/assets/01-home.png">    </p:cNvPr>
           <p:cNvPicPr>
             <a:picLocks noChangeAspect="1"/>
           </p:cNvPicPr>
@@ -6560,7 +6560,7 @@
       </p:sp>
       <p:pic>
         <p:nvPicPr>
-          <p:cNvPr id="11" name="Image 0" descr="/home/azureuser/projects/yeaft-web-code-agent/.yeaft/worktrees/showcase-editorial-ppt/artifacts/showcase/assets/04-session-conversation.png">    </p:cNvPr>
+          <p:cNvPr id="11" name="Image 0" descr="/home/azureuser/projects/yeaft-web-code-agent/.yeaft/worktrees/fix-pr-1669-review-blockers/artifacts/showcase/assets/04-session-conversation.png">    </p:cNvPr>
           <p:cNvPicPr>
             <a:picLocks noChangeAspect="1"/>
           </p:cNvPicPr>
@@ -6793,7 +6793,7 @@
       </p:sp>
       <p:pic>
         <p:nvPicPr>
-          <p:cNvPr id="5" name="Image 0" descr="/home/azureuser/projects/yeaft-web-code-agent/.yeaft/worktrees/showcase-editorial-ppt/artifacts/showcase/assets/05-session-roster.png">    </p:cNvPr>
+          <p:cNvPr id="5" name="Image 0" descr="/home/azureuser/projects/yeaft-web-code-agent/.yeaft/worktrees/fix-pr-1669-review-blockers/artifacts/showcase/assets/05-session-roster.png">    </p:cNvPr>
           <p:cNvPicPr>
             <a:picLocks noChangeAspect="1"/>
           </p:cNvPicPr>
@@ -8620,7 +8620,7 @@
       </p:sp>
       <p:pic>
         <p:nvPicPr>
-          <p:cNvPr id="5" name="Image 0" descr="/home/azureuser/projects/yeaft-web-code-agent/.yeaft/worktrees/showcase-editorial-ppt/artifacts/showcase/assets/08-workbench-files-correct.png">    </p:cNvPr>
+          <p:cNvPr id="5" name="Image 0" descr="/home/azureuser/projects/yeaft-web-code-agent/.yeaft/worktrees/fix-pr-1669-review-blockers/artifacts/showcase/assets/08-workbench-files-correct.png">    </p:cNvPr>
           <p:cNvPicPr>
             <a:picLocks noChangeAspect="1"/>
           </p:cNvPicPr>
@@ -8671,7 +8671,7 @@
       </p:sp>
       <p:pic>
         <p:nvPicPr>
-          <p:cNvPr id="7" name="Image 1" descr="/home/azureuser/projects/yeaft-web-code-agent/.yeaft/worktrees/showcase-editorial-ppt/artifacts/showcase/assets/08-workbench-terminal-correct.png">    </p:cNvPr>
+          <p:cNvPr id="7" name="Image 1" descr="/home/azureuser/projects/yeaft-web-code-agent/.yeaft/worktrees/fix-pr-1669-review-blockers/artifacts/showcase/assets/08-workbench-terminal-correct.png">    </p:cNvPr>
           <p:cNvPicPr>
             <a:picLocks noChangeAspect="1"/>
           </p:cNvPicPr>
@@ -9396,7 +9396,7 @@
       </p:sp>
       <p:pic>
         <p:nvPicPr>
-          <p:cNvPr id="14" name="Image 0" descr="/home/azureuser/projects/yeaft-web-code-agent/.yeaft/worktrees/showcase-editorial-ppt/artifacts/showcase/assets/09-work-center-structure.png">    </p:cNvPr>
+          <p:cNvPr id="14" name="Image 0" descr="/home/azureuser/projects/yeaft-web-code-agent/.yeaft/worktrees/fix-pr-1669-review-blockers/artifacts/showcase/assets/09-work-center-structure.png">    </p:cNvPr>
           <p:cNvPicPr>
             <a:picLocks noChangeAspect="1"/>
           </p:cNvPicPr>

</xml_diff>

<commit_message>
docs: lead showcase with cross-device AI teams and task automation
</commit_message>
<xml_diff>
--- a/artifacts/showcase/yeaft-editorial-minimal.pptx
+++ b/artifacts/showcase/yeaft-editorial-minimal.pptx
@@ -513,7 +513,7 @@
           <a:p>
             <a:r>
               <a:rPr lang="en-US" dirty="0"/>
-              <a:t>Audience: engineers seeing Yeaft for the first time. The central promise is inspectability, not guaranteed autonomous success. All UI data in this deck is staged; the inspection command is captured by the screenshot script.</a:t>
+              <a:t>开场：Yeaft 是跨设备、面向任务的 AI 产品。手机是入口，不是算力所在地；你可以从手机发起复杂工作，由所连接机器上的 Agent 执行。多 VP 是团队，System Prompt 是职责与工作规则，Work Center 让目标跨越单轮对话持续推进。不要把“from anywhere”解释为离线可用：需要能访问 Server，执行 Agent 也必须在线。</a:t>
             </a:r>
             <a:endParaRPr lang="en-US" dirty="0"/>
           </a:p>
@@ -601,7 +601,7 @@
           <a:p>
             <a:r>
               <a:rPr lang="en-US" dirty="0"/>
-              <a:t>Scheduling has dependency/workspace conflict constraints, but read mode is not a sandbox: it does not filter write tools. No promise of complete isolation or success. The example syntax check has not satisfied behavioral acceptance criteria.</a:t>
+              <a:t>把“纯自动化”说成有边界的目标执行：在目标、权限和验收明确时自动推进，不必逐轮发送继续；缺少用户决策或外部副作用无法确认安全时，应进入 waiting/attention，而不是盲目重试。当前 Work Center 为 Preview。Prompts 和 read 标签都不是沙箱，不能承诺绝对隔离。完成必须经过验收门禁，不能把一次模型回复或一个 Run 结束说成整个任务完成。</a:t>
             </a:r>
             <a:endParaRPr lang="en-US" dirty="0"/>
           </a:p>
@@ -689,7 +689,7 @@
           <a:p>
             <a:r>
               <a:rPr lang="en-US" dirty="0"/>
-              <a:t>This is the inspection example handoff, not the release evidence for this presentation. No source was changed by the example. Actual capture revision and command exit status are recorded in assets/capture-manifest.json; staged reviewer text is not independent PR approval.</a:t>
+              <a:t>竞争力来自四种能力的组合，不宣称市场唯一，也不做未实测的竞品功能矩阵。让听众记住：移动访问不是缩小的聊天框，多 VP 不是换头像，Prompt 可控不是一次性提醒，Work Center 不是聊天记录归档。这一页用于回收主线，不再重复产品拓扑或只读检查证据。</a:t>
             </a:r>
             <a:endParaRPr lang="en-US" dirty="0"/>
           </a:p>
@@ -777,7 +777,7 @@
           <a:p>
             <a:r>
               <a:rPr lang="en-US" dirty="0"/>
-              <a:t>Single entry point is the canonical repository README, which contains current setup instructions. This link is independent of any locally running server or demo credentials.</a:t>
+              <a:t>收尾：建议现场从手机打开已连接 Agent 的 Session，给一个边界清晰的任务，展示角色和规则，再去 Work Center 创建带验收标准的目标。建议试用任务为修复一个小 bug、加一个回归测试、准备待审查 patch；它是试用建议，不是本稿声称已完成的结果。先按 README 配置，不默认授权自动部署。</a:t>
             </a:r>
             <a:endParaRPr lang="en-US" dirty="0"/>
           </a:p>
@@ -865,7 +865,7 @@
           <a:p>
             <a:r>
               <a:rPr lang="en-US" dirty="0"/>
-              <a:t>Frame these as questions a team needs to answer, not claims that competing tools always lose context or evidence.</a:t>
+              <a:t>先说人的痛点，而不是堆技术名词。提出一个全场贯穿的使用场景：不在电脑旁时，把带验收标准的 bug 修复交给 AI。它是演示建议，不是已完成的客户案例。三类阻力是设备限制、手动协调和逐轮催促。不声称所有竞品都有这些缺点。</a:t>
             </a:r>
             <a:endParaRPr lang="en-US" dirty="0"/>
           </a:p>
@@ -953,7 +953,7 @@
           <a:p>
             <a:r>
               <a:rPr lang="en-US" dirty="0"/>
-              <a:t>Browser connects through Server authentication and relay to a local Agent. Session is the conversation unit with 1..N VPs. Work Center has its own WorkItems/Actions/Runs and storage; this is not a shared task identity or automatic Session migration.</a:t>
+              <a:t>讲清手机为什么不只是聊天窗口：浏览器经过 Server 的鉴权和中继，连接用户选择的 Agent。文件、Shell 和模型调用在 Agent 一侧执行，手机不需要运行这些工具。桌面、手机浏览器访问同一 Agent 所属的持久 Session；跨 Agent 不是同一份 Session。Session 和 Work Center 是不同的持久对象，不自动迁移。需要网络可达和在线 Agent。</a:t>
             </a:r>
             <a:endParaRPr lang="en-US" dirty="0"/>
           </a:p>
@@ -1041,7 +1041,7 @@
           <a:p>
             <a:r>
               <a:rPr lang="en-US" dirty="0"/>
-              <a:t>Example throughout slides 4–11: inspect agent/yeaft/session.js and run node --check. This is a read-only syntax inspection, not a code change, integration test, approved patch, or production delivery. Screenshot must show the user request and corresponding named response.</a:t>
+              <a:t>展示真正的移动端响应式界面，不用手机外框代替能力证明。讲用户动作：选择 Agent 和 Session、发起需求、查看回复、在需要时补充决策。图中为隔离环境的只读语法检查示例，只证明 UI 展示，不声称已在手机上完成 bug 修复或实测了跨公网设备接力。演示时可以打开手机浏览器操作同一 Agent 的 Session。</a:t>
             </a:r>
             <a:endParaRPr lang="en-US" dirty="0"/>
           </a:p>
@@ -1129,7 +1129,7 @@
           <a:p>
             <a:r>
               <a:rPr lang="en-US" dirty="0"/>
-              <a:t>The screenshot must show both a roster and readable named contributions. The demonstration is not evidence that these VPs performed a real independent review of this presentation.</a:t>
+              <a:t>VP 是 Virtual Person，不是另一台机器。一个 Session 可以有 1..N 个 VP：从一个助手起步，需要时加入实现、审查、研究等不同角色。用户 mention 可以选中成员；VP 间明确交接需要工具路由。截图中的 Linus 和 Martin 是演示配置，不是每个 Session 都内置的强制流程，也不构成对本 PPT 的真实独立审查。</a:t>
             </a:r>
             <a:endParaRPr lang="en-US" dirty="0"/>
           </a:p>
@@ -1217,7 +1217,7 @@
           <a:p>
             <a:r>
               <a:rPr lang="en-US" dirty="0"/>
-              <a:t>A configurable collaboration example. Linus and Martin illustrate separate responsibilities, not a fixed product workflow or a claim that multiple VPs automatically guarantee independent review.</a:t>
+              <a:t>这是产品差异点，不再把 VP 只讲成两个头像。用户可以配置 VP persona prompt；Project instruction 和工作目录 CLAUDE.md / AGENTS.md 提供共享规则。这里展示的是可配置指令示例，不是 UI 截图或已经实施的强制策略。System Prompt 定义 AI 如何工作，但并非 OS sandbox 或绝对安全保证；运行时权限与工具边界仍独立生效。</a:t>
             </a:r>
             <a:endParaRPr lang="en-US" dirty="0"/>
           </a:p>
@@ -1305,7 +1305,7 @@
           <a:p>
             <a:r>
               <a:rPr lang="en-US" dirty="0"/>
-              <a:t>Explicit routing transfers responsibility. These are recommended review handoff fields, not an automatic runtime proof that a reviewer is independent. Real approval for this deck belongs in the PR audit, not this staged walkthrough.</a:t>
+              <a:t>过渡：Session 适合人和 AI 共同探索，Work Center 适合目标明确后的自动化执行。用户交的是目标、约束和验收，而不是每一步 prompt。概念图说明面向任务的使用方式，不暗示所有任务采用固定 VP 顺序、无限重试或自动成功。Work Center 不等于另一种 chat mode，也不是把 Session transcript 自动转换过去。</a:t>
             </a:r>
             <a:endParaRPr lang="en-US" dirty="0"/>
           </a:p>
@@ -1393,7 +1393,7 @@
           <a:p>
             <a:r>
               <a:rPr lang="en-US" dirty="0"/>
-              <a:t>Real Files and Terminal components from the screenshot manifest source revision. Transport is staged. Terminal output replays the actual local syntax check collected by the script. The syntax command does not verify runtime behavior.</a:t>
+              <a:t>工具和文件把“AI 说做了”连接到可查看的实际工作环境。保留用户认可的真实 Files 和 Terminal 组件截图。这里的 terminal 只回放实际 node --check 结果；截图里的语法检查不是 bug 修复证明，也不是完整测试。讲清楚这一句即可，不要把全场重新讲成语法检查教学。</a:t>
             </a:r>
             <a:endParaRPr lang="en-US" dirty="0"/>
           </a:p>
@@ -1481,7 +1481,7 @@
           <a:p>
             <a:r>
               <a:rPr lang="en-US" dirty="0"/>
-              <a:t>Work Center is a separate durable execution system. This staged WorkItem continues the inspection scenario as an example of an explicitly created long-running goal; no automatic transfer of Session identity, shared transcript, or guaranteed successful completion is implied.</a:t>
+              <a:t>展示 Work Center 的实际界面，把它从数据结构介绍变成“任务不是随聊天窗口消失”的价值。WorkItem 持久化目标和验收，Action 是工作单元，Run 是一次执行。在线 Agent 执行不依赖浏览器持续打开；Agent 下线无法继续做事，重启恢复要受状态和副作用安全边界控制。演示 WorkItem 仍是 staged 只读检查，不是已经跑完的复杂自动化案例。</a:t>
             </a:r>
             <a:endParaRPr lang="en-US" dirty="0"/>
           </a:p>
@@ -2036,7 +2036,7 @@
                   <a:srgbClr val="8B5E3C"/>
                 </a:solidFill>
               </a:rPr>
-              <a:t>FROM REQUEST TO EVIDENCE</a:t>
+              <a:t>CROSS-DEVICE · TASK-ORIENTED AI</a:t>
             </a:r>
             <a:endParaRPr lang="en-US" sz="1200" dirty="0"/>
           </a:p>
@@ -2072,7 +2072,7 @@
                   <a:srgbClr val="1D1D1B"/>
                 </a:solidFill>
               </a:rPr>
-              <a:t>An answer is a start.</a:t>
+              <a:t>Your AI team. Real work.</a:t>
             </a:r>
             <a:endParaRPr lang="en-US" sz="3800" dirty="0"/>
           </a:p>
@@ -2086,7 +2086,7 @@
                   <a:srgbClr val="1D1D1B"/>
                 </a:solidFill>
               </a:rPr>
-              <a:t>Show the engineering behind it.</a:t>
+              <a:t>From anywhere.</a:t>
             </a:r>
             <a:endParaRPr lang="en-US" sz="3800" dirty="0"/>
           </a:p>
@@ -2124,7 +2124,7 @@
         <p:spPr>
           <a:xfrm>
             <a:off x="667512" y="4114800"/>
-            <a:ext cx="10012680" cy="1005840"/>
+            <a:ext cx="10515600" cy="1005840"/>
           </a:xfrm>
           <a:prstGeom prst="rect">
             <a:avLst/>
@@ -2145,7 +2145,7 @@
                   <a:srgbClr val="686761"/>
                 </a:solidFill>
               </a:rPr>
-              <a:t>Yeaft connects a browser workspace to your local Agent—</a:t>
+              <a:t>Direct complex tasks from your phone.</a:t>
             </a:r>
             <a:endParaRPr lang="en-US" sz="2300" dirty="0"/>
           </a:p>
@@ -2159,7 +2159,7 @@
                   <a:srgbClr val="686761"/>
                 </a:solidFill>
               </a:rPr>
-              <a:t>with visible conversations, specialists, files, and terminal output.</a:t>
+              <a:t>Let your AI team work on the machines you connect.</a:t>
             </a:r>
             <a:endParaRPr lang="en-US" sz="2300" dirty="0"/>
           </a:p>
@@ -2174,30 +2174,30 @@
         <p:spPr>
           <a:xfrm>
             <a:off x="667512" y="5724144"/>
-            <a:ext cx="9144000" cy="274320"/>
-          </a:xfrm>
-          <a:prstGeom prst="rect">
-            <a:avLst/>
-          </a:prstGeom>
-          <a:noFill/>
-          <a:ln/>
-        </p:spPr>
-        <p:txBody>
-          <a:bodyPr wrap="square" lIns="0" tIns="0" rIns="0" bIns="0" rtlCol="0" anchor="ctr"/>
-          <a:lstStyle/>
-          <a:p>
-            <a:pPr indent="0" marL="0">
-              <a:buNone/>
-            </a:pPr>
-            <a:r>
-              <a:rPr lang="en-US" sz="1400" dirty="0">
-                <a:solidFill>
-                  <a:srgbClr val="686761"/>
-                </a:solidFill>
-              </a:rPr>
-              <a:t>A product walkthrough for engineers</a:t>
-            </a:r>
-            <a:endParaRPr lang="en-US" sz="1400" dirty="0"/>
+            <a:ext cx="10881360" cy="320040"/>
+          </a:xfrm>
+          <a:prstGeom prst="rect">
+            <a:avLst/>
+          </a:prstGeom>
+          <a:noFill/>
+          <a:ln/>
+        </p:spPr>
+        <p:txBody>
+          <a:bodyPr wrap="square" lIns="0" tIns="0" rIns="0" bIns="0" rtlCol="0" anchor="ctr"/>
+          <a:lstStyle/>
+          <a:p>
+            <a:pPr indent="0" marL="0">
+              <a:buNone/>
+            </a:pPr>
+            <a:r>
+              <a:rPr lang="en-US" sz="1600" dirty="0">
+                <a:solidFill>
+                  <a:srgbClr val="8B5E3C"/>
+                </a:solidFill>
+              </a:rPr>
+              <a:t>Multi-VP teams  /  Your system prompts  /  Work Center automation</a:t>
+            </a:r>
+            <a:endParaRPr lang="en-US" sz="1600" dirty="0"/>
           </a:p>
         </p:txBody>
       </p:sp>
@@ -2301,7 +2301,7 @@
                   <a:srgbClr val="8B5E3C"/>
                 </a:solidFill>
               </a:rPr>
-              <a:t>THE BOUNDARY</a:t>
+              <a:t>AUTONOMY WITHOUT SURRENDERING CONTROL</a:t>
             </a:r>
             <a:endParaRPr lang="en-US" sz="1100" dirty="0"/>
           </a:p>
@@ -2337,7 +2337,7 @@
                   <a:srgbClr val="1D1D1B"/>
                 </a:solidFill>
               </a:rPr>
-              <a:t>Progress is useful only when its limits are visible.</a:t>
+              <a:t>Let AI keep working. Keep the decisions that matter.</a:t>
             </a:r>
             <a:endParaRPr lang="en-US" sz="3000" dirty="0"/>
           </a:p>
@@ -2373,7 +2373,7 @@
                   <a:srgbClr val="8B5E3C"/>
                 </a:solidFill>
               </a:rPr>
-              <a:t>COORDINATION</a:t>
+              <a:t>AUTOMATE</a:t>
             </a:r>
             <a:endParaRPr lang="en-US" sz="1200" dirty="0"/>
           </a:p>
@@ -2409,7 +2409,7 @@
                   <a:srgbClr val="1D1D1B"/>
                 </a:solidFill>
               </a:rPr>
-              <a:t>Check prerequisites.</a:t>
+              <a:t>Beyond chat turns.</a:t>
             </a:r>
             <a:endParaRPr lang="en-US" sz="2200" dirty="0"/>
           </a:p>
@@ -2445,7 +2445,7 @@
                   <a:srgbClr val="686761"/>
                 </a:solidFill>
               </a:rPr>
-              <a:t>Results and workspace conflicts affect what can run next. A “read” label is not a sandbox.</a:t>
+              <a:t>Ready work runs on the Agent. Outcomes and bounded retries do not need a fresh prompt each time.</a:t>
             </a:r>
             <a:endParaRPr lang="en-US" sz="1700" dirty="0"/>
           </a:p>
@@ -2481,7 +2481,7 @@
                   <a:srgbClr val="8B5E3C"/>
                 </a:solidFill>
               </a:rPr>
-              <a:t>STOPPING</a:t>
+              <a:t>INTERVENE</a:t>
             </a:r>
             <a:endParaRPr lang="en-US" sz="1200" dirty="0"/>
           </a:p>
@@ -2517,7 +2517,7 @@
                   <a:srgbClr val="1D1D1B"/>
                 </a:solidFill>
               </a:rPr>
-              <a:t>Expose the blocker.</a:t>
+              <a:t>Keep key decisions.</a:t>
             </a:r>
             <a:endParaRPr lang="en-US" sz="2200" dirty="0"/>
           </a:p>
@@ -2553,7 +2553,7 @@
                   <a:srgbClr val="686761"/>
                 </a:solidFill>
               </a:rPr>
-              <a:t>Missing evidence, failure, or a required decision must not be reported as success.</a:t>
+              <a:t>Review progress. Supply missing input. Resolve blockers or stop the work.</a:t>
             </a:r>
             <a:endParaRPr lang="en-US" sz="1700" dirty="0"/>
           </a:p>
@@ -2589,7 +2589,7 @@
                   <a:srgbClr val="8B5E3C"/>
                 </a:solidFill>
               </a:rPr>
-              <a:t>ACCEPTANCE</a:t>
+              <a:t>ACCEPT</a:t>
             </a:r>
             <a:endParaRPr lang="en-US" sz="1200" dirty="0"/>
           </a:p>
@@ -2625,7 +2625,7 @@
                   <a:srgbClr val="1D1D1B"/>
                 </a:solidFill>
               </a:rPr>
-              <a:t>Verify the goal.</a:t>
+              <a:t>Against the goal.</a:t>
             </a:r>
             <a:endParaRPr lang="en-US" sz="2200" dirty="0"/>
           </a:p>
@@ -2661,7 +2661,7 @@
                   <a:srgbClr val="686761"/>
                 </a:solidFill>
               </a:rPr>
-              <a:t>The inspection passed syntax. Startup behavior remains untested; that limit stays visible.</a:t>
+              <a:t>Completion depends on acceptance checks—not merely an assistant saying “done”.</a:t>
             </a:r>
             <a:endParaRPr lang="en-US" sz="1700" dirty="0"/>
           </a:p>
@@ -2676,30 +2676,30 @@
         <p:spPr>
           <a:xfrm>
             <a:off x="713232" y="5870448"/>
-            <a:ext cx="10698480" cy="329184"/>
-          </a:xfrm>
-          <a:prstGeom prst="rect">
-            <a:avLst/>
-          </a:prstGeom>
-          <a:noFill/>
-          <a:ln/>
-        </p:spPr>
-        <p:txBody>
-          <a:bodyPr wrap="square" lIns="0" tIns="0" rIns="0" bIns="0" rtlCol="0" anchor="ctr"/>
-          <a:lstStyle/>
-          <a:p>
-            <a:pPr indent="0" marL="0">
-              <a:buNone/>
-            </a:pPr>
-            <a:r>
-              <a:rPr lang="en-US" sz="2000" b="1" dirty="0">
+            <a:ext cx="10698480" cy="365760"/>
+          </a:xfrm>
+          <a:prstGeom prst="rect">
+            <a:avLst/>
+          </a:prstGeom>
+          <a:noFill/>
+          <a:ln/>
+        </p:spPr>
+        <p:txBody>
+          <a:bodyPr wrap="square" lIns="0" tIns="0" rIns="0" bIns="0" rtlCol="0" anchor="ctr"/>
+          <a:lstStyle/>
+          <a:p>
+            <a:pPr indent="0" marL="0">
+              <a:buNone/>
+            </a:pPr>
+            <a:r>
+              <a:rPr lang="en-US" sz="1700" dirty="0">
                 <a:solidFill>
                   <a:srgbClr val="8B5E3C"/>
                 </a:solidFill>
               </a:rPr>
-              <a:t>A finished response is not proof of a finished engineering task.</a:t>
-            </a:r>
-            <a:endParaRPr lang="en-US" sz="2000" dirty="0"/>
+              <a:t>Within configured tools and permissions. Instructions are not a sandbox.</a:t>
+            </a:r>
+            <a:endParaRPr lang="en-US" sz="1700" dirty="0"/>
           </a:p>
         </p:txBody>
       </p:sp>
@@ -2803,7 +2803,7 @@
                   <a:srgbClr val="8B5E3C"/>
                 </a:solidFill>
               </a:rPr>
-              <a:t>THE HANDOFF</a:t>
+              <a:t>WHY THIS COMBINATION MATTERS</a:t>
             </a:r>
             <a:endParaRPr lang="en-US" sz="1100" dirty="0"/>
           </a:p>
@@ -2839,7 +2839,7 @@
                   <a:srgbClr val="1D1D1B"/>
                 </a:solidFill>
               </a:rPr>
-              <a:t>What can the next engineer check?</a:t>
+              <a:t>An AI workspace built around getting work done.</a:t>
             </a:r>
             <a:endParaRPr lang="en-US" sz="3000" dirty="0"/>
           </a:p>
@@ -2875,7 +2875,7 @@
                   <a:srgbClr val="686761"/>
                 </a:solidFill>
               </a:rPr>
-              <a:t>Inspection example: keep the result narrow enough to be true.</a:t>
+              <a:t>Access, team design, behavior control, and automation belong together.</a:t>
             </a:r>
             <a:endParaRPr lang="en-US" sz="1500" dirty="0"/>
           </a:p>
@@ -2889,31 +2889,31 @@
         </p:nvSpPr>
         <p:spPr>
           <a:xfrm>
-            <a:off x="704088" y="2651760"/>
-            <a:ext cx="2011680" cy="292608"/>
-          </a:xfrm>
-          <a:prstGeom prst="rect">
-            <a:avLst/>
-          </a:prstGeom>
-          <a:noFill/>
-          <a:ln/>
-        </p:spPr>
-        <p:txBody>
-          <a:bodyPr wrap="square" lIns="0" tIns="0" rIns="0" bIns="0" rtlCol="0" anchor="ctr"/>
-          <a:lstStyle/>
-          <a:p>
-            <a:pPr indent="0" marL="0">
-              <a:buNone/>
-            </a:pPr>
-            <a:r>
-              <a:rPr lang="en-US" sz="1100" b="1" dirty="0">
+            <a:off x="704088" y="2697480"/>
+            <a:ext cx="2194560" cy="292608"/>
+          </a:xfrm>
+          <a:prstGeom prst="rect">
+            <a:avLst/>
+          </a:prstGeom>
+          <a:noFill/>
+          <a:ln/>
+        </p:spPr>
+        <p:txBody>
+          <a:bodyPr wrap="square" lIns="0" tIns="0" rIns="0" bIns="0" rtlCol="0" anchor="ctr"/>
+          <a:lstStyle/>
+          <a:p>
+            <a:pPr indent="0" marL="0">
+              <a:buNone/>
+            </a:pPr>
+            <a:r>
+              <a:rPr lang="en-US" sz="1200" b="1" dirty="0">
                 <a:solidFill>
                   <a:srgbClr val="8B5E3C"/>
                 </a:solidFill>
               </a:rPr>
-              <a:t>SOURCE</a:t>
-            </a:r>
-            <a:endParaRPr lang="en-US" sz="1100" dirty="0"/>
+              <a:t>CROSS-DEVICE</a:t>
+            </a:r>
+            <a:endParaRPr lang="en-US" sz="1200" dirty="0"/>
           </a:p>
         </p:txBody>
       </p:sp>
@@ -2925,31 +2925,31 @@
         </p:nvSpPr>
         <p:spPr>
           <a:xfrm>
-            <a:off x="2743200" y="2633472"/>
-            <a:ext cx="8714232" cy="365760"/>
-          </a:xfrm>
-          <a:prstGeom prst="rect">
-            <a:avLst/>
-          </a:prstGeom>
-          <a:noFill/>
-          <a:ln/>
-        </p:spPr>
-        <p:txBody>
-          <a:bodyPr wrap="square" lIns="0" tIns="0" rIns="0" bIns="0" rtlCol="0" anchor="ctr"/>
-          <a:lstStyle/>
-          <a:p>
-            <a:pPr indent="0" marL="0">
-              <a:buNone/>
-            </a:pPr>
-            <a:r>
-              <a:rPr lang="en-US" sz="1600" dirty="0">
+            <a:off x="2971800" y="2679192"/>
+            <a:ext cx="8485632" cy="402336"/>
+          </a:xfrm>
+          <a:prstGeom prst="rect">
+            <a:avLst/>
+          </a:prstGeom>
+          <a:noFill/>
+          <a:ln/>
+        </p:spPr>
+        <p:txBody>
+          <a:bodyPr wrap="square" lIns="0" tIns="0" rIns="0" bIns="0" rtlCol="0" anchor="ctr"/>
+          <a:lstStyle/>
+          <a:p>
+            <a:pPr indent="0" marL="0">
+              <a:buNone/>
+            </a:pPr>
+            <a:r>
+              <a:rPr lang="en-US" sz="1800" dirty="0">
                 <a:solidFill>
                   <a:srgbClr val="1D1D1B"/>
                 </a:solidFill>
               </a:rPr>
-              <a:t>agent/yeaft/session.js · inspected, not modified</a:t>
-            </a:r>
-            <a:endParaRPr lang="en-US" sz="1600" dirty="0"/>
+              <a:t>Direct real Agent-side work from a phone or desktop.</a:t>
+            </a:r>
+            <a:endParaRPr lang="en-US" sz="1800" dirty="0"/>
           </a:p>
         </p:txBody>
       </p:sp>
@@ -2961,7 +2961,7 @@
         </p:nvSpPr>
         <p:spPr>
           <a:xfrm>
-            <a:off x="704088" y="3099816"/>
+            <a:off x="704088" y="3236976"/>
             <a:ext cx="10762488" cy="0"/>
           </a:xfrm>
           <a:prstGeom prst="line">
@@ -2984,31 +2984,31 @@
         </p:nvSpPr>
         <p:spPr>
           <a:xfrm>
-            <a:off x="704088" y="3218688"/>
-            <a:ext cx="2011680" cy="292608"/>
-          </a:xfrm>
-          <a:prstGeom prst="rect">
-            <a:avLst/>
-          </a:prstGeom>
-          <a:noFill/>
-          <a:ln/>
-        </p:spPr>
-        <p:txBody>
-          <a:bodyPr wrap="square" lIns="0" tIns="0" rIns="0" bIns="0" rtlCol="0" anchor="ctr"/>
-          <a:lstStyle/>
-          <a:p>
-            <a:pPr indent="0" marL="0">
-              <a:buNone/>
-            </a:pPr>
-            <a:r>
-              <a:rPr lang="en-US" sz="1100" b="1" dirty="0">
+            <a:off x="704088" y="3392424"/>
+            <a:ext cx="2194560" cy="292608"/>
+          </a:xfrm>
+          <a:prstGeom prst="rect">
+            <a:avLst/>
+          </a:prstGeom>
+          <a:noFill/>
+          <a:ln/>
+        </p:spPr>
+        <p:txBody>
+          <a:bodyPr wrap="square" lIns="0" tIns="0" rIns="0" bIns="0" rtlCol="0" anchor="ctr"/>
+          <a:lstStyle/>
+          <a:p>
+            <a:pPr indent="0" marL="0">
+              <a:buNone/>
+            </a:pPr>
+            <a:r>
+              <a:rPr lang="en-US" sz="1200" b="1" dirty="0">
                 <a:solidFill>
                   <a:srgbClr val="8B5E3C"/>
                 </a:solidFill>
               </a:rPr>
-              <a:t>REVISION</a:t>
-            </a:r>
-            <a:endParaRPr lang="en-US" sz="1100" dirty="0"/>
+              <a:t>MULTI-VP</a:t>
+            </a:r>
+            <a:endParaRPr lang="en-US" sz="1200" dirty="0"/>
           </a:p>
         </p:txBody>
       </p:sp>
@@ -3020,31 +3020,31 @@
         </p:nvSpPr>
         <p:spPr>
           <a:xfrm>
-            <a:off x="2743200" y="3200400"/>
-            <a:ext cx="8714232" cy="365760"/>
-          </a:xfrm>
-          <a:prstGeom prst="rect">
-            <a:avLst/>
-          </a:prstGeom>
-          <a:noFill/>
-          <a:ln/>
-        </p:spPr>
-        <p:txBody>
-          <a:bodyPr wrap="square" lIns="0" tIns="0" rIns="0" bIns="0" rtlCol="0" anchor="ctr"/>
-          <a:lstStyle/>
-          <a:p>
-            <a:pPr indent="0" marL="0">
-              <a:buNone/>
-            </a:pPr>
-            <a:r>
-              <a:rPr lang="en-US" sz="1600" dirty="0">
+            <a:off x="2971800" y="3374136"/>
+            <a:ext cx="8485632" cy="402336"/>
+          </a:xfrm>
+          <a:prstGeom prst="rect">
+            <a:avLst/>
+          </a:prstGeom>
+          <a:noFill/>
+          <a:ln/>
+        </p:spPr>
+        <p:txBody>
+          <a:bodyPr wrap="square" lIns="0" tIns="0" rIns="0" bIns="0" rtlCol="0" anchor="ctr"/>
+          <a:lstStyle/>
+          <a:p>
+            <a:pPr indent="0" marL="0">
+              <a:buNone/>
+            </a:pPr>
+            <a:r>
+              <a:rPr lang="en-US" sz="1800" dirty="0">
                 <a:solidFill>
                   <a:srgbClr val="1D1D1B"/>
                 </a:solidFill>
               </a:rPr>
-              <a:t>Exact UI/source commit recorded in capture-manifest.json</a:t>
-            </a:r>
-            <a:endParaRPr lang="en-US" sz="1600" dirty="0"/>
+              <a:t>Split responsibilities while keeping contributions visible.</a:t>
+            </a:r>
+            <a:endParaRPr lang="en-US" sz="1800" dirty="0"/>
           </a:p>
         </p:txBody>
       </p:sp>
@@ -3056,7 +3056,7 @@
         </p:nvSpPr>
         <p:spPr>
           <a:xfrm>
-            <a:off x="704088" y="3666744"/>
+            <a:off x="704088" y="3931920"/>
             <a:ext cx="10762488" cy="0"/>
           </a:xfrm>
           <a:prstGeom prst="line">
@@ -3079,31 +3079,31 @@
         </p:nvSpPr>
         <p:spPr>
           <a:xfrm>
-            <a:off x="704088" y="3785616"/>
-            <a:ext cx="2011680" cy="292608"/>
-          </a:xfrm>
-          <a:prstGeom prst="rect">
-            <a:avLst/>
-          </a:prstGeom>
-          <a:noFill/>
-          <a:ln/>
-        </p:spPr>
-        <p:txBody>
-          <a:bodyPr wrap="square" lIns="0" tIns="0" rIns="0" bIns="0" rtlCol="0" anchor="ctr"/>
-          <a:lstStyle/>
-          <a:p>
-            <a:pPr indent="0" marL="0">
-              <a:buNone/>
-            </a:pPr>
-            <a:r>
-              <a:rPr lang="en-US" sz="1100" b="1" dirty="0">
+            <a:off x="704088" y="4087368"/>
+            <a:ext cx="2194560" cy="292608"/>
+          </a:xfrm>
+          <a:prstGeom prst="rect">
+            <a:avLst/>
+          </a:prstGeom>
+          <a:noFill/>
+          <a:ln/>
+        </p:spPr>
+        <p:txBody>
+          <a:bodyPr wrap="square" lIns="0" tIns="0" rIns="0" bIns="0" rtlCol="0" anchor="ctr"/>
+          <a:lstStyle/>
+          <a:p>
+            <a:pPr indent="0" marL="0">
+              <a:buNone/>
+            </a:pPr>
+            <a:r>
+              <a:rPr lang="en-US" sz="1200" b="1" dirty="0">
                 <a:solidFill>
                   <a:srgbClr val="8B5E3C"/>
                 </a:solidFill>
               </a:rPr>
-              <a:t>COMMAND</a:t>
-            </a:r>
-            <a:endParaRPr lang="en-US" sz="1100" dirty="0"/>
+              <a:t>SYSTEM PROMPTS</a:t>
+            </a:r>
+            <a:endParaRPr lang="en-US" sz="1200" dirty="0"/>
           </a:p>
         </p:txBody>
       </p:sp>
@@ -3115,31 +3115,31 @@
         </p:nvSpPr>
         <p:spPr>
           <a:xfrm>
-            <a:off x="2743200" y="3767328"/>
-            <a:ext cx="8714232" cy="365760"/>
-          </a:xfrm>
-          <a:prstGeom prst="rect">
-            <a:avLst/>
-          </a:prstGeom>
-          <a:noFill/>
-          <a:ln/>
-        </p:spPr>
-        <p:txBody>
-          <a:bodyPr wrap="square" lIns="0" tIns="0" rIns="0" bIns="0" rtlCol="0" anchor="ctr"/>
-          <a:lstStyle/>
-          <a:p>
-            <a:pPr indent="0" marL="0">
-              <a:buNone/>
-            </a:pPr>
-            <a:r>
-              <a:rPr lang="en-US" sz="1600" dirty="0">
+            <a:off x="2971800" y="4069080"/>
+            <a:ext cx="8485632" cy="402336"/>
+          </a:xfrm>
+          <a:prstGeom prst="rect">
+            <a:avLst/>
+          </a:prstGeom>
+          <a:noFill/>
+          <a:ln/>
+        </p:spPr>
+        <p:txBody>
+          <a:bodyPr wrap="square" lIns="0" tIns="0" rIns="0" bIns="0" rtlCol="0" anchor="ctr"/>
+          <a:lstStyle/>
+          <a:p>
+            <a:pPr indent="0" marL="0">
+              <a:buNone/>
+            </a:pPr>
+            <a:r>
+              <a:rPr lang="en-US" sz="1800" dirty="0">
                 <a:solidFill>
                   <a:srgbClr val="1D1D1B"/>
                 </a:solidFill>
               </a:rPr>
-              <a:t>node --check agent/yeaft/session.js · recorded exit result</a:t>
-            </a:r>
-            <a:endParaRPr lang="en-US" sz="1600" dirty="0"/>
+              <a:t>Shape reusable roles and shared working rules.</a:t>
+            </a:r>
+            <a:endParaRPr lang="en-US" sz="1800" dirty="0"/>
           </a:p>
         </p:txBody>
       </p:sp>
@@ -3151,7 +3151,7 @@
         </p:nvSpPr>
         <p:spPr>
           <a:xfrm>
-            <a:off x="704088" y="4233672"/>
+            <a:off x="704088" y="4626864"/>
             <a:ext cx="10762488" cy="0"/>
           </a:xfrm>
           <a:prstGeom prst="line">
@@ -3174,31 +3174,31 @@
         </p:nvSpPr>
         <p:spPr>
           <a:xfrm>
-            <a:off x="704088" y="4352544"/>
-            <a:ext cx="2011680" cy="292608"/>
-          </a:xfrm>
-          <a:prstGeom prst="rect">
-            <a:avLst/>
-          </a:prstGeom>
-          <a:noFill/>
-          <a:ln/>
-        </p:spPr>
-        <p:txBody>
-          <a:bodyPr wrap="square" lIns="0" tIns="0" rIns="0" bIns="0" rtlCol="0" anchor="ctr"/>
-          <a:lstStyle/>
-          <a:p>
-            <a:pPr indent="0" marL="0">
-              <a:buNone/>
-            </a:pPr>
-            <a:r>
-              <a:rPr lang="en-US" sz="1100" b="1" dirty="0">
+            <a:off x="704088" y="4782312"/>
+            <a:ext cx="2194560" cy="292608"/>
+          </a:xfrm>
+          <a:prstGeom prst="rect">
+            <a:avLst/>
+          </a:prstGeom>
+          <a:noFill/>
+          <a:ln/>
+        </p:spPr>
+        <p:txBody>
+          <a:bodyPr wrap="square" lIns="0" tIns="0" rIns="0" bIns="0" rtlCol="0" anchor="ctr"/>
+          <a:lstStyle/>
+          <a:p>
+            <a:pPr indent="0" marL="0">
+              <a:buNone/>
+            </a:pPr>
+            <a:r>
+              <a:rPr lang="en-US" sz="1200" b="1" dirty="0">
                 <a:solidFill>
                   <a:srgbClr val="8B5E3C"/>
                 </a:solidFill>
               </a:rPr>
-              <a:t>REVIEW</a:t>
-            </a:r>
-            <a:endParaRPr lang="en-US" sz="1100" dirty="0"/>
+              <a:t>WORK CENTER</a:t>
+            </a:r>
+            <a:endParaRPr lang="en-US" sz="1200" dirty="0"/>
           </a:p>
         </p:txBody>
       </p:sp>
@@ -3210,257 +3210,67 @@
         </p:nvSpPr>
         <p:spPr>
           <a:xfrm>
-            <a:off x="2743200" y="4334256"/>
-            <a:ext cx="8714232" cy="365760"/>
-          </a:xfrm>
-          <a:prstGeom prst="rect">
-            <a:avLst/>
-          </a:prstGeom>
-          <a:noFill/>
-          <a:ln/>
-        </p:spPr>
-        <p:txBody>
-          <a:bodyPr wrap="square" lIns="0" tIns="0" rIns="0" bIns="0" rtlCol="0" anchor="ctr"/>
-          <a:lstStyle/>
-          <a:p>
-            <a:pPr indent="0" marL="0">
-              <a:buNone/>
-            </a:pPr>
-            <a:r>
-              <a:rPr lang="en-US" sz="1600" dirty="0">
+            <a:off x="2971800" y="4764024"/>
+            <a:ext cx="8485632" cy="402336"/>
+          </a:xfrm>
+          <a:prstGeom prst="rect">
+            <a:avLst/>
+          </a:prstGeom>
+          <a:noFill/>
+          <a:ln/>
+        </p:spPr>
+        <p:txBody>
+          <a:bodyPr wrap="square" lIns="0" tIns="0" rIns="0" bIns="0" rtlCol="0" anchor="ctr"/>
+          <a:lstStyle/>
+          <a:p>
+            <a:pPr indent="0" marL="0">
+              <a:buNone/>
+            </a:pPr>
+            <a:r>
+              <a:rPr lang="en-US" sz="1800" dirty="0">
                 <a:solidFill>
                   <a:srgbClr val="1D1D1B"/>
                 </a:solidFill>
               </a:rPr>
-              <a:t>Demo reviewer challenges scope · not a real PR approval</a:t>
-            </a:r>
-            <a:endParaRPr lang="en-US" sz="1600" dirty="0"/>
-          </a:p>
-        </p:txBody>
-      </p:sp>
-      <p:sp>
-        <p:nvSpPr>
-          <p:cNvPr id="17" name="Shape 14"/>
-          <p:cNvSpPr/>
-          <p:nvPr/>
-        </p:nvSpPr>
-        <p:spPr>
-          <a:xfrm>
-            <a:off x="704088" y="4800600"/>
-            <a:ext cx="10762488" cy="0"/>
-          </a:xfrm>
-          <a:prstGeom prst="line">
-            <a:avLst/>
-          </a:prstGeom>
-          <a:noFill/>
-          <a:ln w="7620">
-            <a:solidFill>
-              <a:srgbClr val="D7D2C8"/>
-            </a:solidFill>
-            <a:prstDash val="solid"/>
-          </a:ln>
-        </p:spPr>
-      </p:sp>
-      <p:sp>
-        <p:nvSpPr>
-          <p:cNvPr id="18" name="Text 15"/>
-          <p:cNvSpPr/>
-          <p:nvPr/>
-        </p:nvSpPr>
-        <p:spPr>
-          <a:xfrm>
-            <a:off x="704088" y="4919472"/>
-            <a:ext cx="2011680" cy="292608"/>
-          </a:xfrm>
-          <a:prstGeom prst="rect">
-            <a:avLst/>
-          </a:prstGeom>
-          <a:noFill/>
-          <a:ln/>
-        </p:spPr>
-        <p:txBody>
-          <a:bodyPr wrap="square" lIns="0" tIns="0" rIns="0" bIns="0" rtlCol="0" anchor="ctr"/>
-          <a:lstStyle/>
-          <a:p>
-            <a:pPr indent="0" marL="0">
-              <a:buNone/>
-            </a:pPr>
-            <a:r>
-              <a:rPr lang="en-US" sz="1100" b="1" dirty="0">
+              <a:t>Delegate persistent goals, not just individual replies.</a:t>
+            </a:r>
+            <a:endParaRPr lang="en-US" sz="1800" dirty="0"/>
+          </a:p>
+        </p:txBody>
+      </p:sp>
+      <p:sp>
+        <p:nvSpPr>
+          <p:cNvPr id="17" name="Text 14"/>
+          <p:cNvSpPr/>
+          <p:nvPr/>
+        </p:nvSpPr>
+        <p:spPr>
+          <a:xfrm>
+            <a:off x="704088" y="5907024"/>
+            <a:ext cx="10698480" cy="365760"/>
+          </a:xfrm>
+          <a:prstGeom prst="rect">
+            <a:avLst/>
+          </a:prstGeom>
+          <a:noFill/>
+          <a:ln/>
+        </p:spPr>
+        <p:txBody>
+          <a:bodyPr wrap="square" lIns="0" tIns="0" rIns="0" bIns="0" rtlCol="0" anchor="ctr"/>
+          <a:lstStyle/>
+          <a:p>
+            <a:pPr indent="0" marL="0">
+              <a:buNone/>
+            </a:pPr>
+            <a:r>
+              <a:rPr lang="en-US" sz="2200" b="1" dirty="0">
                 <a:solidFill>
                   <a:srgbClr val="8B5E3C"/>
                 </a:solidFill>
               </a:rPr>
-              <a:t>ACCEPTANCE</a:t>
-            </a:r>
-            <a:endParaRPr lang="en-US" sz="1100" dirty="0"/>
-          </a:p>
-        </p:txBody>
-      </p:sp>
-      <p:sp>
-        <p:nvSpPr>
-          <p:cNvPr id="19" name="Text 16"/>
-          <p:cNvSpPr/>
-          <p:nvPr/>
-        </p:nvSpPr>
-        <p:spPr>
-          <a:xfrm>
-            <a:off x="2743200" y="4901184"/>
-            <a:ext cx="8714232" cy="365760"/>
-          </a:xfrm>
-          <a:prstGeom prst="rect">
-            <a:avLst/>
-          </a:prstGeom>
-          <a:noFill/>
-          <a:ln/>
-        </p:spPr>
-        <p:txBody>
-          <a:bodyPr wrap="square" lIns="0" tIns="0" rIns="0" bIns="0" rtlCol="0" anchor="ctr"/>
-          <a:lstStyle/>
-          <a:p>
-            <a:pPr indent="0" marL="0">
-              <a:buNone/>
-            </a:pPr>
-            <a:r>
-              <a:rPr lang="en-US" sz="1600" dirty="0">
-                <a:solidFill>
-                  <a:srgbClr val="1D1D1B"/>
-                </a:solidFill>
-              </a:rPr>
-              <a:t>Syntax check only · startup behavior remains untested</a:t>
-            </a:r>
-            <a:endParaRPr lang="en-US" sz="1600" dirty="0"/>
-          </a:p>
-        </p:txBody>
-      </p:sp>
-      <p:sp>
-        <p:nvSpPr>
-          <p:cNvPr id="20" name="Shape 17"/>
-          <p:cNvSpPr/>
-          <p:nvPr/>
-        </p:nvSpPr>
-        <p:spPr>
-          <a:xfrm>
-            <a:off x="704088" y="5367528"/>
-            <a:ext cx="10762488" cy="0"/>
-          </a:xfrm>
-          <a:prstGeom prst="line">
-            <a:avLst/>
-          </a:prstGeom>
-          <a:noFill/>
-          <a:ln w="7620">
-            <a:solidFill>
-              <a:srgbClr val="D7D2C8"/>
-            </a:solidFill>
-            <a:prstDash val="solid"/>
-          </a:ln>
-        </p:spPr>
-      </p:sp>
-      <p:sp>
-        <p:nvSpPr>
-          <p:cNvPr id="21" name="Text 18"/>
-          <p:cNvSpPr/>
-          <p:nvPr/>
-        </p:nvSpPr>
-        <p:spPr>
-          <a:xfrm>
-            <a:off x="704088" y="5486400"/>
-            <a:ext cx="2011680" cy="292608"/>
-          </a:xfrm>
-          <a:prstGeom prst="rect">
-            <a:avLst/>
-          </a:prstGeom>
-          <a:noFill/>
-          <a:ln/>
-        </p:spPr>
-        <p:txBody>
-          <a:bodyPr wrap="square" lIns="0" tIns="0" rIns="0" bIns="0" rtlCol="0" anchor="ctr"/>
-          <a:lstStyle/>
-          <a:p>
-            <a:pPr indent="0" marL="0">
-              <a:buNone/>
-            </a:pPr>
-            <a:r>
-              <a:rPr lang="en-US" sz="1100" b="1" dirty="0">
-                <a:solidFill>
-                  <a:srgbClr val="8B5E3C"/>
-                </a:solidFill>
-              </a:rPr>
-              <a:t>RISK / NEXT STEP</a:t>
-            </a:r>
-            <a:endParaRPr lang="en-US" sz="1100" dirty="0"/>
-          </a:p>
-        </p:txBody>
-      </p:sp>
-      <p:sp>
-        <p:nvSpPr>
-          <p:cNvPr id="22" name="Text 19"/>
-          <p:cNvSpPr/>
-          <p:nvPr/>
-        </p:nvSpPr>
-        <p:spPr>
-          <a:xfrm>
-            <a:off x="2743200" y="5468112"/>
-            <a:ext cx="8714232" cy="365760"/>
-          </a:xfrm>
-          <a:prstGeom prst="rect">
-            <a:avLst/>
-          </a:prstGeom>
-          <a:noFill/>
-          <a:ln/>
-        </p:spPr>
-        <p:txBody>
-          <a:bodyPr wrap="square" lIns="0" tIns="0" rIns="0" bIns="0" rtlCol="0" anchor="ctr"/>
-          <a:lstStyle/>
-          <a:p>
-            <a:pPr indent="0" marL="0">
-              <a:buNone/>
-            </a:pPr>
-            <a:r>
-              <a:rPr lang="en-US" sz="1600" dirty="0">
-                <a:solidFill>
-                  <a:srgbClr val="1D1D1B"/>
-                </a:solidFill>
-              </a:rPr>
-              <a:t>No runtime claim · add a startup test before changing behavior</a:t>
-            </a:r>
-            <a:endParaRPr lang="en-US" sz="1600" dirty="0"/>
-          </a:p>
-        </p:txBody>
-      </p:sp>
-      <p:sp>
-        <p:nvSpPr>
-          <p:cNvPr id="23" name="Text 20"/>
-          <p:cNvSpPr/>
-          <p:nvPr/>
-        </p:nvSpPr>
-        <p:spPr>
-          <a:xfrm>
-            <a:off x="704088" y="6428232"/>
-            <a:ext cx="10149840" cy="256032"/>
-          </a:xfrm>
-          <a:prstGeom prst="rect">
-            <a:avLst/>
-          </a:prstGeom>
-          <a:noFill/>
-          <a:ln/>
-        </p:spPr>
-        <p:txBody>
-          <a:bodyPr wrap="square" lIns="0" tIns="0" rIns="0" bIns="0" rtlCol="0" anchor="ctr"/>
-          <a:lstStyle/>
-          <a:p>
-            <a:pPr indent="0" marL="0">
-              <a:buNone/>
-            </a:pPr>
-            <a:r>
-              <a:rPr lang="en-US" sz="1000" dirty="0">
-                <a:solidFill>
-                  <a:srgbClr val="686761"/>
-                </a:solidFill>
-              </a:rPr>
-              <a:t>Staged walkthrough · Actual presentation validation is documented separately</a:t>
-            </a:r>
-            <a:endParaRPr lang="en-US" sz="1000" dirty="0"/>
+              <a:t>A phone-sized entry point. A task-sized ambition.</a:t>
+            </a:r>
+            <a:endParaRPr lang="en-US" sz="2200" dirty="0"/>
           </a:p>
         </p:txBody>
       </p:sp>
@@ -3564,7 +3374,7 @@
                   <a:srgbClr val="8B5E3C"/>
                 </a:solidFill>
               </a:rPr>
-              <a:t>TRY IT WITH A SMALL, BOUNDED TASK</a:t>
+              <a:t>TRY YEAFT</a:t>
             </a:r>
             <a:endParaRPr lang="en-US" sz="1100" dirty="0"/>
           </a:p>
@@ -3600,7 +3410,7 @@
                   <a:srgbClr val="1D1D1B"/>
                 </a:solidFill>
               </a:rPr>
-              <a:t>Bring one question. Leave with something you can check.</a:t>
+              <a:t>Your next task does not have to wait for your desk.</a:t>
             </a:r>
             <a:endParaRPr lang="en-US" sz="3000" dirty="0"/>
           </a:p>
@@ -3672,7 +3482,7 @@
                   <a:srgbClr val="1D1D1B"/>
                 </a:solidFill>
               </a:rPr>
-              <a:t>Connect an Agent.</a:t>
+              <a:t>Connect your machine.</a:t>
             </a:r>
             <a:endParaRPr lang="en-US" sz="2200" dirty="0"/>
           </a:p>
@@ -3708,7 +3518,7 @@
                   <a:srgbClr val="686761"/>
                 </a:solidFill>
               </a:rPr>
-              <a:t>Follow the setup guide for your local environment.</a:t>
+              <a:t>Run an Agent where your project and tools already live.</a:t>
             </a:r>
             <a:endParaRPr lang="en-US" sz="1700" dirty="0"/>
           </a:p>
@@ -3780,7 +3590,7 @@
                   <a:srgbClr val="1D1D1B"/>
                 </a:solidFill>
               </a:rPr>
-              <a:t>Open a Session.</a:t>
+              <a:t>Shape your AI team.</a:t>
             </a:r>
             <a:endParaRPr lang="en-US" sz="2200" dirty="0"/>
           </a:p>
@@ -3816,7 +3626,7 @@
                   <a:srgbClr val="686761"/>
                 </a:solidFill>
               </a:rPr>
-              <a:t>Ask a concrete question about one file or behavior.</a:t>
+              <a:t>Choose VPs. Define their roles and your project rules.</a:t>
             </a:r>
             <a:endParaRPr lang="en-US" sz="1700" dirty="0"/>
           </a:p>
@@ -3888,7 +3698,7 @@
                   <a:srgbClr val="1D1D1B"/>
                 </a:solidFill>
               </a:rPr>
-              <a:t>Inspect the evidence.</a:t>
+              <a:t>Delegate a real goal.</a:t>
             </a:r>
             <a:endParaRPr lang="en-US" sz="2200" dirty="0"/>
           </a:p>
@@ -3924,7 +3734,7 @@
                   <a:srgbClr val="686761"/>
                 </a:solidFill>
               </a:rPr>
-              <a:t>Read the source, command result, and remaining limitations.</a:t>
+              <a:t>Start from your phone. Give Work Center a bounded task and clear acceptance criteria.</a:t>
             </a:r>
             <a:endParaRPr lang="en-US" sz="1700" dirty="0"/>
           </a:p>
@@ -4098,7 +3908,7 @@
                   <a:srgbClr val="8B5E3C"/>
                 </a:solidFill>
               </a:rPr>
-              <a:t>THE PROBLEM</a:t>
+              <a:t>WHY YEAFT</a:t>
             </a:r>
             <a:endParaRPr lang="en-US" sz="1100" dirty="0"/>
           </a:p>
@@ -4134,7 +3944,7 @@
                   <a:srgbClr val="1D1D1B"/>
                 </a:solidFill>
               </a:rPr>
-              <a:t>A useful answer still leaves three questions.</a:t>
+              <a:t>Delegate the work—not another round of prompting.</a:t>
             </a:r>
             <a:endParaRPr lang="en-US" sz="3000" dirty="0"/>
           </a:p>
@@ -4143,6 +3953,42 @@
       <p:sp>
         <p:nvSpPr>
           <p:cNvPr id="5" name="Text 2"/>
+          <p:cNvSpPr/>
+          <p:nvPr/>
+        </p:nvSpPr>
+        <p:spPr>
+          <a:xfrm>
+            <a:off x="640080" y="1901952"/>
+            <a:ext cx="10652760" cy="512064"/>
+          </a:xfrm>
+          <a:prstGeom prst="rect">
+            <a:avLst/>
+          </a:prstGeom>
+          <a:noFill/>
+          <a:ln/>
+        </p:spPr>
+        <p:txBody>
+          <a:bodyPr wrap="square" lIns="0" tIns="0" rIns="0" bIns="0" rtlCol="0" anchor="t"/>
+          <a:lstStyle/>
+          <a:p>
+            <a:pPr indent="0" marL="0">
+              <a:buNone/>
+            </a:pPr>
+            <a:r>
+              <a:rPr lang="en-US" sz="1500" dirty="0">
+                <a:solidFill>
+                  <a:srgbClr val="686761"/>
+                </a:solidFill>
+              </a:rPr>
+              <a:t>Imagine asking from your phone: “Fix this bug, add a regression test, and prepare a reviewed patch.”</a:t>
+            </a:r>
+            <a:endParaRPr lang="en-US" sz="1500" dirty="0"/>
+          </a:p>
+        </p:txBody>
+      </p:sp>
+      <p:sp>
+        <p:nvSpPr>
+          <p:cNvPr id="6" name="Text 3"/>
           <p:cNvSpPr/>
           <p:nvPr/>
         </p:nvSpPr>
@@ -4170,7 +4016,7 @@
                   <a:srgbClr val="8B5E3C"/>
                 </a:solidFill>
               </a:rPr>
-              <a:t>01 / CONTEXT</a:t>
+              <a:t>ACCESS</a:t>
             </a:r>
             <a:endParaRPr lang="en-US" sz="1200" dirty="0"/>
           </a:p>
@@ -4178,7 +4024,7 @@
       </p:sp>
       <p:sp>
         <p:nvSpPr>
-          <p:cNvPr id="6" name="Text 3"/>
+          <p:cNvPr id="7" name="Text 4"/>
           <p:cNvSpPr/>
           <p:nvPr/>
         </p:nvSpPr>
@@ -4206,7 +4052,7 @@
                   <a:srgbClr val="1D1D1B"/>
                 </a:solidFill>
               </a:rPr>
-              <a:t>What was requested?</a:t>
+              <a:t>Away from your desk.</a:t>
             </a:r>
             <a:endParaRPr lang="en-US" sz="2200" dirty="0"/>
           </a:p>
@@ -4214,7 +4060,7 @@
       </p:sp>
       <p:sp>
         <p:nvSpPr>
-          <p:cNvPr id="7" name="Text 4"/>
+          <p:cNvPr id="8" name="Text 5"/>
           <p:cNvSpPr/>
           <p:nvPr/>
         </p:nvSpPr>
@@ -4242,7 +4088,7 @@
                   <a:srgbClr val="686761"/>
                 </a:solidFill>
               </a:rPr>
-              <a:t>The goal and constraints need to remain close to the response.</a:t>
+              <a:t>The code and tools are on another machine. You still need to move the task forward.</a:t>
             </a:r>
             <a:endParaRPr lang="en-US" sz="1700" dirty="0"/>
           </a:p>
@@ -4250,7 +4096,7 @@
       </p:sp>
       <p:sp>
         <p:nvSpPr>
-          <p:cNvPr id="8" name="Text 5"/>
+          <p:cNvPr id="9" name="Text 6"/>
           <p:cNvSpPr/>
           <p:nvPr/>
         </p:nvSpPr>
@@ -4278,7 +4124,7 @@
                   <a:srgbClr val="8B5E3C"/>
                 </a:solidFill>
               </a:rPr>
-              <a:t>02 / RESPONSIBILITY</a:t>
+              <a:t>COORDINATION</a:t>
             </a:r>
             <a:endParaRPr lang="en-US" sz="1200" dirty="0"/>
           </a:p>
@@ -4286,7 +4132,7 @@
       </p:sp>
       <p:sp>
         <p:nvSpPr>
-          <p:cNvPr id="9" name="Text 6"/>
+          <p:cNvPr id="10" name="Text 7"/>
           <p:cNvSpPr/>
           <p:nvPr/>
         </p:nvSpPr>
@@ -4314,7 +4160,7 @@
                   <a:srgbClr val="1D1D1B"/>
                 </a:solidFill>
               </a:rPr>
-              <a:t>Who did what?</a:t>
+              <a:t>More than one role.</a:t>
             </a:r>
             <a:endParaRPr lang="en-US" sz="2200" dirty="0"/>
           </a:p>
@@ -4322,7 +4168,7 @@
       </p:sp>
       <p:sp>
         <p:nvSpPr>
-          <p:cNvPr id="10" name="Text 7"/>
+          <p:cNvPr id="11" name="Text 8"/>
           <p:cNvSpPr/>
           <p:nvPr/>
         </p:nvSpPr>
@@ -4350,7 +4196,7 @@
                   <a:srgbClr val="686761"/>
                 </a:solidFill>
               </a:rPr>
-              <a:t>Implementation and independent judgment are different contributions.</a:t>
+              <a:t>Investigation, implementation, and review need distinct responsibilities.</a:t>
             </a:r>
             <a:endParaRPr lang="en-US" sz="1700" dirty="0"/>
           </a:p>
@@ -4358,7 +4204,7 @@
       </p:sp>
       <p:sp>
         <p:nvSpPr>
-          <p:cNvPr id="11" name="Text 8"/>
+          <p:cNvPr id="12" name="Text 9"/>
           <p:cNvSpPr/>
           <p:nvPr/>
         </p:nvSpPr>
@@ -4386,7 +4232,7 @@
                   <a:srgbClr val="8B5E3C"/>
                 </a:solidFill>
               </a:rPr>
-              <a:t>03 / EVIDENCE</a:t>
+              <a:t>FOLLOW-THROUGH</a:t>
             </a:r>
             <a:endParaRPr lang="en-US" sz="1200" dirty="0"/>
           </a:p>
@@ -4394,7 +4240,7 @@
       </p:sp>
       <p:sp>
         <p:nvSpPr>
-          <p:cNvPr id="12" name="Text 9"/>
+          <p:cNvPr id="13" name="Text 10"/>
           <p:cNvSpPr/>
           <p:nvPr/>
         </p:nvSpPr>
@@ -4422,7 +4268,7 @@
                   <a:srgbClr val="1D1D1B"/>
                 </a:solidFill>
               </a:rPr>
-              <a:t>What can I check?</a:t>
+              <a:t>Beyond one reply.</a:t>
             </a:r>
             <a:endParaRPr lang="en-US" sz="2200" dirty="0"/>
           </a:p>
@@ -4430,7 +4276,7 @@
       </p:sp>
       <p:sp>
         <p:nvSpPr>
-          <p:cNvPr id="13" name="Text 10"/>
+          <p:cNvPr id="14" name="Text 11"/>
           <p:cNvSpPr/>
           <p:nvPr/>
         </p:nvSpPr>
@@ -4458,7 +4304,7 @@
                   <a:srgbClr val="686761"/>
                 </a:solidFill>
               </a:rPr>
-              <a:t>A file, a command, and a scoped result are stronger than “done”.</a:t>
+              <a:t>Complex work needs execution, checks, recovery, and a clear completion condition.</a:t>
             </a:r>
             <a:endParaRPr lang="en-US" sz="1700" dirty="0"/>
           </a:p>
@@ -4466,7 +4312,7 @@
       </p:sp>
       <p:sp>
         <p:nvSpPr>
-          <p:cNvPr id="14" name="Text 11"/>
+          <p:cNvPr id="15" name="Text 12"/>
           <p:cNvSpPr/>
           <p:nvPr/>
         </p:nvSpPr>
@@ -4489,14 +4335,14 @@
               <a:buNone/>
             </a:pPr>
             <a:r>
-              <a:rPr lang="en-US" sz="1600" dirty="0">
+              <a:rPr lang="en-US" sz="1800" dirty="0">
                 <a:solidFill>
                   <a:srgbClr val="8B5E3C"/>
                 </a:solidFill>
               </a:rPr>
-              <a:t>This walkthrough follows one small inspection—not a claimed production fix.</a:t>
-            </a:r>
-            <a:endParaRPr lang="en-US" sz="1600" dirty="0"/>
+              <a:t>Yeaft brings access, team control, and task execution into one product.</a:t>
+            </a:r>
+            <a:endParaRPr lang="en-US" sz="1800" dirty="0"/>
           </a:p>
         </p:txBody>
       </p:sp>
@@ -4600,7 +4446,7 @@
                   <a:srgbClr val="8B5E3C"/>
                 </a:solidFill>
               </a:rPr>
-              <a:t>PRODUCT MAP</a:t>
+              <a:t>CROSS-DEVICE EXECUTION</a:t>
             </a:r>
             <a:endParaRPr lang="en-US" sz="1100" dirty="0"/>
           </a:p>
@@ -4636,7 +4482,7 @@
                   <a:srgbClr val="1D1D1B"/>
                 </a:solidFill>
               </a:rPr>
-              <a:t>The browser is the workspace. The Agent does the work.</a:t>
+              <a:t>Your phone is the control surface. The Agent does the work.</a:t>
             </a:r>
             <a:endParaRPr lang="en-US" sz="3000" dirty="0"/>
           </a:p>
@@ -4672,7 +4518,7 @@
                   <a:srgbClr val="686761"/>
                 </a:solidFill>
               </a:rPr>
-              <a:t>Two execution responsibilities live on the Agent. They are not two names for the same conversation.</a:t>
+              <a:t>Use a mobile or desktop browser. Connect the machine that has your project and tools.</a:t>
             </a:r>
             <a:endParaRPr lang="en-US" sz="1500" dirty="0"/>
           </a:p>
@@ -4728,14 +4574,14 @@
               <a:buNone/>
             </a:pPr>
             <a:r>
-              <a:rPr lang="en-US" sz="1900" b="1" dirty="0">
+              <a:rPr lang="en-US" sz="1800" b="1" dirty="0">
                 <a:solidFill>
                   <a:srgbClr val="1D1D1B"/>
                 </a:solidFill>
               </a:rPr>
-              <a:t>BROWSER</a:t>
-            </a:r>
-            <a:endParaRPr lang="en-US" sz="1900" dirty="0"/>
+              <a:t>ANY BROWSER</a:t>
+            </a:r>
+            <a:endParaRPr lang="en-US" sz="1800" dirty="0"/>
           </a:p>
         </p:txBody>
       </p:sp>
@@ -4769,7 +4615,7 @@
                   <a:srgbClr val="686761"/>
                 </a:solidFill>
               </a:rPr>
-              <a:t>Conversation + workbench</a:t>
+              <a:t>Phone + tablet + desktop</a:t>
             </a:r>
             <a:endParaRPr lang="en-US" sz="1500" dirty="0"/>
           </a:p>
@@ -4975,7 +4821,7 @@
                   <a:srgbClr val="1D1D1B"/>
                 </a:solidFill>
               </a:rPr>
-              <a:t>LOCAL AGENT</a:t>
+              <a:t>YOUR CONNECTED AGENT</a:t>
             </a:r>
             <a:endParaRPr lang="en-US" sz="1900" dirty="0"/>
           </a:p>
@@ -5011,7 +4857,7 @@
                   <a:srgbClr val="1D1D1B"/>
                 </a:solidFill>
               </a:rPr>
-              <a:t>Session</a:t>
+              <a:t>Session + multi-VP team</a:t>
             </a:r>
             <a:endParaRPr lang="en-US" sz="2000" dirty="0"/>
           </a:p>
@@ -5047,7 +4893,7 @@
                   <a:srgbClr val="686761"/>
                 </a:solidFill>
               </a:rPr>
-              <a:t>Conversation with 1..N Virtual Persons</a:t>
+              <a:t>Interactive work, with named contributors</a:t>
             </a:r>
             <a:endParaRPr lang="en-US" sz="1500" dirty="0"/>
           </a:p>
@@ -5119,7 +4965,7 @@
                   <a:srgbClr val="686761"/>
                 </a:solidFill>
               </a:rPr>
-              <a:t>Durable goals, Actions, and Runs</a:t>
+              <a:t>Persistent goals and automated execution</a:t>
             </a:r>
             <a:endParaRPr lang="en-US" sz="1500" dirty="0"/>
           </a:p>
@@ -5134,7 +4980,7 @@
         <p:spPr>
           <a:xfrm>
             <a:off x="685800" y="5120640"/>
-            <a:ext cx="5852160" cy="640080"/>
+            <a:ext cx="5852160" cy="731520"/>
           </a:xfrm>
           <a:prstGeom prst="rect">
             <a:avLst/>
@@ -5156,6 +5002,20 @@
                 </a:solidFill>
               </a:rPr>
               <a:t>Files, shell, and provider access stay Agent-side.</a:t>
+            </a:r>
+            <a:endParaRPr lang="en-US" sz="1600" dirty="0"/>
+          </a:p>
+          <a:p>
+            <a:pPr indent="0" marL="0">
+              <a:buNone/>
+            </a:pPr>
+            <a:r>
+              <a:rPr lang="en-US" sz="1600" dirty="0">
+                <a:solidFill>
+                  <a:srgbClr val="686761"/>
+                </a:solidFill>
+              </a:rPr>
+              <a:t>Requires a reachable Server and an online Agent.</a:t>
             </a:r>
             <a:endParaRPr lang="en-US" sz="1600" dirty="0"/>
           </a:p>
@@ -5261,7 +5121,7 @@
                   <a:srgbClr val="8B5E3C"/>
                 </a:solidFill>
               </a:rPr>
-              <a:t>01 / KEEP THE REQUEST VISIBLE</a:t>
+              <a:t>01 / CROSS-DEVICE ACCESS</a:t>
             </a:r>
             <a:endParaRPr lang="en-US" sz="1100" dirty="0"/>
           </a:p>
@@ -5297,7 +5157,7 @@
                   <a:srgbClr val="1D1D1B"/>
                 </a:solidFill>
               </a:rPr>
-              <a:t>Start with a question you can actually verify.</a:t>
+              <a:t>Step away from the desk—not from the task.</a:t>
             </a:r>
             <a:endParaRPr lang="en-US" sz="3000" dirty="0"/>
           </a:p>
@@ -5305,7 +5165,7 @@
       </p:sp>
       <p:pic>
         <p:nvPicPr>
-          <p:cNvPr id="5" name="Image 0" descr="/home/azureuser/projects/yeaft-web-code-agent/.yeaft/worktrees/showcase-story-visual-refresh/artifacts/showcase/assets/04-session-conversation.png">    </p:cNvPr>
+          <p:cNvPr id="5" name="Image 0" descr="/home/azureuser/projects/yeaft-web-code-agent/.yeaft/worktrees/showcase-task-first/artifacts/showcase/assets/04-session-mobile.png">    </p:cNvPr>
           <p:cNvPicPr>
             <a:picLocks noChangeAspect="1"/>
           </p:cNvPicPr>
@@ -5319,8 +5179,8 @@
         </p:blipFill>
         <p:spPr>
           <a:xfrm>
-            <a:off x="1790852" y="2148840"/>
-            <a:ext cx="5150815" cy="3931920"/>
+            <a:off x="1385251" y="2057400"/>
+            <a:ext cx="1892938" cy="4096512"/>
           </a:xfrm>
           <a:prstGeom prst="rect">
             <a:avLst/>
@@ -5335,8 +5195,8 @@
         </p:nvSpPr>
         <p:spPr>
           <a:xfrm>
-            <a:off x="8385048" y="2560320"/>
-            <a:ext cx="2971800" cy="228600"/>
+            <a:off x="4526280" y="2532888"/>
+            <a:ext cx="6629400" cy="274320"/>
           </a:xfrm>
           <a:prstGeom prst="rect">
             <a:avLst/>
@@ -5357,7 +5217,7 @@
                   <a:srgbClr val="8B5E3C"/>
                 </a:solidFill>
               </a:rPr>
-              <a:t>REQUEST</a:t>
+              <a:t>START FROM YOUR PHONE</a:t>
             </a:r>
             <a:endParaRPr lang="en-US" sz="1200" dirty="0"/>
           </a:p>
@@ -5371,31 +5231,45 @@
         </p:nvSpPr>
         <p:spPr>
           <a:xfrm>
-            <a:off x="8385048" y="2953512"/>
-            <a:ext cx="2971800" cy="685800"/>
-          </a:xfrm>
-          <a:prstGeom prst="rect">
-            <a:avLst/>
-          </a:prstGeom>
-          <a:noFill/>
-          <a:ln/>
-        </p:spPr>
-        <p:txBody>
-          <a:bodyPr wrap="square" lIns="0" tIns="0" rIns="0" bIns="0" rtlCol="0" anchor="ctr"/>
-          <a:lstStyle/>
-          <a:p>
-            <a:pPr indent="0" marL="0">
-              <a:buNone/>
-            </a:pPr>
-            <a:r>
-              <a:rPr lang="en-US" sz="2300" b="1" dirty="0">
+            <a:off x="4526280" y="2953512"/>
+            <a:ext cx="6629400" cy="960120"/>
+          </a:xfrm>
+          <a:prstGeom prst="rect">
+            <a:avLst/>
+          </a:prstGeom>
+          <a:noFill/>
+          <a:ln/>
+        </p:spPr>
+        <p:txBody>
+          <a:bodyPr wrap="square" lIns="0" tIns="0" rIns="0" bIns="0" rtlCol="0" anchor="ctr"/>
+          <a:lstStyle/>
+          <a:p>
+            <a:pPr indent="0" marL="0">
+              <a:buNone/>
+            </a:pPr>
+            <a:r>
+              <a:rPr lang="en-US" sz="2600" b="1" dirty="0">
                 <a:solidFill>
                   <a:srgbClr val="1D1D1B"/>
                 </a:solidFill>
               </a:rPr>
-              <a:t>Inspect Session startup.</a:t>
-            </a:r>
-            <a:endParaRPr lang="en-US" sz="2300" dirty="0"/>
+              <a:t>The project stays on the Agent.</a:t>
+            </a:r>
+            <a:endParaRPr lang="en-US" sz="2600" dirty="0"/>
+          </a:p>
+          <a:p>
+            <a:pPr indent="0" marL="0">
+              <a:buNone/>
+            </a:pPr>
+            <a:r>
+              <a:rPr lang="en-US" sz="2600" b="1" dirty="0">
+                <a:solidFill>
+                  <a:srgbClr val="1D1D1B"/>
+                </a:solidFill>
+              </a:rPr>
+              <a:t>The conversation comes with you.</a:t>
+            </a:r>
+            <a:endParaRPr lang="en-US" sz="2600" dirty="0"/>
           </a:p>
         </p:txBody>
       </p:sp>
@@ -5407,67 +5281,81 @@
         </p:nvSpPr>
         <p:spPr>
           <a:xfrm>
-            <a:off x="8385048" y="3977640"/>
-            <a:ext cx="2971800" cy="228600"/>
-          </a:xfrm>
-          <a:prstGeom prst="rect">
-            <a:avLst/>
-          </a:prstGeom>
-          <a:noFill/>
-          <a:ln/>
-        </p:spPr>
-        <p:txBody>
-          <a:bodyPr wrap="square" lIns="0" tIns="0" rIns="0" bIns="0" rtlCol="0" anchor="ctr"/>
-          <a:lstStyle/>
-          <a:p>
-            <a:pPr indent="0" marL="0">
-              <a:buNone/>
-            </a:pPr>
-            <a:r>
-              <a:rPr lang="en-US" sz="1200" b="1" dirty="0">
+            <a:off x="4526280" y="4270248"/>
+            <a:ext cx="6629400" cy="914400"/>
+          </a:xfrm>
+          <a:prstGeom prst="rect">
+            <a:avLst/>
+          </a:prstGeom>
+          <a:noFill/>
+          <a:ln/>
+        </p:spPr>
+        <p:txBody>
+          <a:bodyPr wrap="square" lIns="0" tIns="0" rIns="0" bIns="0" rtlCol="0" anchor="t"/>
+          <a:lstStyle/>
+          <a:p>
+            <a:pPr indent="0" marL="0">
+              <a:buNone/>
+            </a:pPr>
+            <a:r>
+              <a:rPr lang="en-US" sz="2000" dirty="0">
+                <a:solidFill>
+                  <a:srgbClr val="686761"/>
+                </a:solidFill>
+              </a:rPr>
+              <a:t>Send the goal. Read named replies.</a:t>
+            </a:r>
+            <a:endParaRPr lang="en-US" sz="2000" dirty="0"/>
+          </a:p>
+          <a:p>
+            <a:pPr indent="0" marL="0">
+              <a:buNone/>
+            </a:pPr>
+            <a:r>
+              <a:rPr lang="en-US" sz="2000" dirty="0">
+                <a:solidFill>
+                  <a:srgbClr val="686761"/>
+                </a:solidFill>
+              </a:rPr>
+              <a:t>Add direction when the work needs a decision.</a:t>
+            </a:r>
+            <a:endParaRPr lang="en-US" sz="2000" dirty="0"/>
+          </a:p>
+        </p:txBody>
+      </p:sp>
+      <p:sp>
+        <p:nvSpPr>
+          <p:cNvPr id="9" name="Text 5"/>
+          <p:cNvSpPr/>
+          <p:nvPr/>
+        </p:nvSpPr>
+        <p:spPr>
+          <a:xfrm>
+            <a:off x="4526280" y="5586984"/>
+            <a:ext cx="6629400" cy="502920"/>
+          </a:xfrm>
+          <a:prstGeom prst="rect">
+            <a:avLst/>
+          </a:prstGeom>
+          <a:noFill/>
+          <a:ln/>
+        </p:spPr>
+        <p:txBody>
+          <a:bodyPr wrap="square" lIns="0" tIns="0" rIns="0" bIns="0" rtlCol="0" anchor="ctr"/>
+          <a:lstStyle/>
+          <a:p>
+            <a:pPr indent="0" marL="0">
+              <a:buNone/>
+            </a:pPr>
+            <a:r>
+              <a:rPr lang="en-US" sz="1500" dirty="0">
                 <a:solidFill>
                   <a:srgbClr val="8B5E3C"/>
                 </a:solidFill>
               </a:rPr>
-              <a:t>RESPONSE</a:t>
-            </a:r>
-            <a:endParaRPr lang="en-US" sz="1200" dirty="0"/>
-          </a:p>
-        </p:txBody>
-      </p:sp>
-      <p:sp>
-        <p:nvSpPr>
-          <p:cNvPr id="9" name="Text 5"/>
-          <p:cNvSpPr/>
-          <p:nvPr/>
-        </p:nvSpPr>
-        <p:spPr>
-          <a:xfrm>
-            <a:off x="8385048" y="4389120"/>
-            <a:ext cx="2971800" cy="1325880"/>
-          </a:xfrm>
-          <a:prstGeom prst="rect">
-            <a:avLst/>
-          </a:prstGeom>
-          <a:noFill/>
-          <a:ln/>
-        </p:spPr>
-        <p:txBody>
-          <a:bodyPr wrap="square" lIns="0" tIns="0" rIns="0" bIns="0" rtlCol="0" anchor="t"/>
-          <a:lstStyle/>
-          <a:p>
-            <a:pPr indent="0" marL="0">
-              <a:buNone/>
-            </a:pPr>
-            <a:r>
-              <a:rPr lang="en-US" sz="1800" dirty="0">
-                <a:solidFill>
-                  <a:srgbClr val="686761"/>
-                </a:solidFill>
-              </a:rPr>
-              <a:t>A named reply links the file and check back to that request.</a:t>
-            </a:r>
-            <a:endParaRPr lang="en-US" sz="1800" dirty="0"/>
+              <a:t>Continue in a desktop browser with the same Agent + Session.</a:t>
+            </a:r>
+            <a:endParaRPr lang="en-US" sz="1500" dirty="0"/>
           </a:p>
         </p:txBody>
       </p:sp>
@@ -5501,7 +5389,7 @@
                   <a:srgbClr val="686761"/>
                 </a:solidFill>
               </a:rPr>
-              <a:t>Real Yeaft UI · Staged inspection demo</a:t>
+              <a:t>Real Yeaft UI · Staged inspection demo · Mobile viewport</a:t>
             </a:r>
             <a:endParaRPr lang="en-US" sz="1000" dirty="0"/>
           </a:p>
@@ -5607,7 +5495,7 @@
                   <a:srgbClr val="8B5E3C"/>
                 </a:solidFill>
               </a:rPr>
-              <a:t>02 / MAKE CONTRIBUTIONS ATTRIBUTABLE</a:t>
+              <a:t>02 / MULTI-VP TEAMS</a:t>
             </a:r>
             <a:endParaRPr lang="en-US" sz="1100" dirty="0"/>
           </a:p>
@@ -5643,7 +5531,7 @@
                   <a:srgbClr val="1D1D1B"/>
                 </a:solidFill>
               </a:rPr>
-              <a:t>See the team—and what each person contributed.</a:t>
+              <a:t>One workspace. Different minds on the problem.</a:t>
             </a:r>
             <a:endParaRPr lang="en-US" sz="3000" dirty="0"/>
           </a:p>
@@ -5651,7 +5539,7 @@
       </p:sp>
       <p:pic>
         <p:nvPicPr>
-          <p:cNvPr id="5" name="Image 0" descr="/home/azureuser/projects/yeaft-web-code-agent/.yeaft/worktrees/showcase-story-visual-refresh/artifacts/showcase/assets/05-session-roster.png">    </p:cNvPr>
+          <p:cNvPr id="5" name="Image 0" descr="/home/azureuser/projects/yeaft-web-code-agent/.yeaft/worktrees/showcase-task-first/artifacts/showcase/assets/05-session-roster.png">    </p:cNvPr>
           <p:cNvPicPr>
             <a:picLocks noChangeAspect="1"/>
           </p:cNvPicPr>
@@ -5703,7 +5591,7 @@
                   <a:srgbClr val="8B5E3C"/>
                 </a:solidFill>
               </a:rPr>
-              <a:t>LINUS</a:t>
+              <a:t>BUILD</a:t>
             </a:r>
             <a:endParaRPr lang="en-US" sz="1200" dirty="0"/>
           </a:p>
@@ -5739,7 +5627,7 @@
                   <a:srgbClr val="686761"/>
                 </a:solidFill>
               </a:rPr>
-              <a:t>Reports the inspected file and syntax result.</a:t>
+              <a:t>Give an implementer a focused responsibility.</a:t>
             </a:r>
             <a:endParaRPr lang="en-US" sz="2000" dirty="0"/>
           </a:p>
@@ -5775,7 +5663,7 @@
                   <a:srgbClr val="8B5E3C"/>
                 </a:solidFill>
               </a:rPr>
-              <a:t>MARTIN</a:t>
+              <a:t>CHALLENGE</a:t>
             </a:r>
             <a:endParaRPr lang="en-US" sz="1200" dirty="0"/>
           </a:p>
@@ -5811,7 +5699,7 @@
                   <a:srgbClr val="686761"/>
                 </a:solidFill>
               </a:rPr>
-              <a:t>Challenges the scope: syntax is not behavior.</a:t>
+              <a:t>Let a reviewer question the result—not just echo it.</a:t>
             </a:r>
             <a:endParaRPr lang="en-US" sz="2000" dirty="0"/>
           </a:p>
@@ -5847,7 +5735,7 @@
                   <a:srgbClr val="686761"/>
                 </a:solidFill>
               </a:rPr>
-              <a:t>Real Yeaft UI · Staged inspection demo</a:t>
+              <a:t>Real Yeaft UI · Staged inspection demo · 1..N VPs per Session</a:t>
             </a:r>
             <a:endParaRPr lang="en-US" sz="1000" dirty="0"/>
           </a:p>
@@ -5953,7 +5841,7 @@
                   <a:srgbClr val="8B5E3C"/>
                 </a:solidFill>
               </a:rPr>
-              <a:t>03 / SEPARATE RESPONSIBILITIES</a:t>
+              <a:t>03 / YOUR SYSTEM PROMPTS</a:t>
             </a:r>
             <a:endParaRPr lang="en-US" sz="1100" dirty="0"/>
           </a:p>
@@ -5989,7 +5877,7 @@
                   <a:srgbClr val="1D1D1B"/>
                 </a:solidFill>
               </a:rPr>
-              <a:t>Give each specialist a different job.</a:t>
+              <a:t>Define how your AI team works.</a:t>
             </a:r>
             <a:endParaRPr lang="en-US" sz="3000" dirty="0"/>
           </a:p>
@@ -6025,7 +5913,7 @@
                   <a:srgbClr val="686761"/>
                 </a:solidFill>
               </a:rPr>
-              <a:t>Example team configuration—not a fixed sequence built into every Session.</a:t>
+              <a:t>Configure VP personas. Carry shared rules through Project instructions and repository docs.</a:t>
             </a:r>
             <a:endParaRPr lang="en-US" sz="1500" dirty="0"/>
           </a:p>
@@ -6061,7 +5949,7 @@
                   <a:srgbClr val="8B5E3C"/>
                 </a:solidFill>
               </a:rPr>
-              <a:t>IMPLEMENTER / LINUS</a:t>
+              <a:t>VP PERSONA / EXAMPLE</a:t>
             </a:r>
             <a:endParaRPr lang="en-US" sz="1200" dirty="0"/>
           </a:p>
@@ -6097,7 +5985,7 @@
                   <a:srgbClr val="1D1D1B"/>
                 </a:solidFill>
               </a:rPr>
-              <a:t>Produce evidence.</a:t>
+              <a:t>Give the role a contract.</a:t>
             </a:r>
             <a:endParaRPr lang="en-US" sz="2200" dirty="0"/>
           </a:p>
@@ -6133,7 +6021,7 @@
                   <a:srgbClr val="686761"/>
                 </a:solidFill>
               </a:rPr>
-              <a:t>Inspect the relevant source.</a:t>
+              <a:t>“Act as an implementer.</a:t>
             </a:r>
             <a:endParaRPr lang="en-US" sz="1700" dirty="0"/>
           </a:p>
@@ -6147,7 +6035,7 @@
                   <a:srgbClr val="686761"/>
                 </a:solidFill>
               </a:rPr>
-              <a:t>Run the bounded check.</a:t>
+              <a:t>Make the smallest useful change.</a:t>
             </a:r>
             <a:endParaRPr lang="en-US" sz="1700" dirty="0"/>
           </a:p>
@@ -6161,7 +6049,7 @@
                   <a:srgbClr val="686761"/>
                 </a:solidFill>
               </a:rPr>
-              <a:t>State exactly what it proves.</a:t>
+              <a:t>Report tests and open risks.”</a:t>
             </a:r>
             <a:endParaRPr lang="en-US" sz="1700" dirty="0"/>
           </a:p>
@@ -6197,7 +6085,7 @@
                   <a:srgbClr val="8B5E3C"/>
                 </a:solidFill>
               </a:rPr>
-              <a:t>REVIEWER / MARTIN</a:t>
+              <a:t>PROJECT RULES / EXAMPLE</a:t>
             </a:r>
             <a:endParaRPr lang="en-US" sz="1200" dirty="0"/>
           </a:p>
@@ -6233,7 +6121,7 @@
                   <a:srgbClr val="1D1D1B"/>
                 </a:solidFill>
               </a:rPr>
-              <a:t>Challenge the claim.</a:t>
+              <a:t>Keep standards consistent.</a:t>
             </a:r>
             <a:endParaRPr lang="en-US" sz="2200" dirty="0"/>
           </a:p>
@@ -6269,7 +6157,7 @@
                   <a:srgbClr val="686761"/>
                 </a:solidFill>
               </a:rPr>
-              <a:t>Read the same revision.</a:t>
+              <a:t>“Review the exact revision.</a:t>
             </a:r>
             <a:endParaRPr lang="en-US" sz="1700" dirty="0"/>
           </a:p>
@@ -6283,7 +6171,7 @@
                   <a:srgbClr val="686761"/>
                 </a:solidFill>
               </a:rPr>
-              <a:t>Check the evidence and its limits.</a:t>
+              <a:t>Ask before deployment.</a:t>
             </a:r>
             <a:endParaRPr lang="en-US" sz="1700" dirty="0"/>
           </a:p>
@@ -6297,7 +6185,7 @@
                   <a:srgbClr val="686761"/>
                 </a:solidFill>
               </a:rPr>
-              <a:t>Return approval or a specific blocker.</a:t>
+              <a:t>Never claim an unrun test passed.”</a:t>
             </a:r>
             <a:endParaRPr lang="en-US" sz="1700" dirty="0"/>
           </a:p>
@@ -6351,14 +6239,14 @@
               <a:buNone/>
             </a:pPr>
             <a:r>
-              <a:rPr lang="en-US" sz="1700" dirty="0">
+              <a:rPr lang="en-US" sz="1800" dirty="0">
                 <a:solidFill>
                   <a:srgbClr val="8B5E3C"/>
                 </a:solidFill>
               </a:rPr>
-              <a:t>For this example: parsing successfully does not prove Session startup works.</a:t>
-            </a:r>
-            <a:endParaRPr lang="en-US" sz="1700" dirty="0"/>
+              <a:t>Reusable instructions—not a one-off reminder in every conversation.</a:t>
+            </a:r>
+            <a:endParaRPr lang="en-US" sz="1800" dirty="0"/>
           </a:p>
         </p:txBody>
       </p:sp>
@@ -6462,7 +6350,7 @@
                   <a:srgbClr val="8B5E3C"/>
                 </a:solidFill>
               </a:rPr>
-              <a:t>04 / HAND OVER SOMETHING REVIEWABLE</a:t>
+              <a:t>04 / TASK-ORIENTED AUTOMATION · PREVIEW</a:t>
             </a:r>
             <a:endParaRPr lang="en-US" sz="1100" dirty="0"/>
           </a:p>
@@ -6498,7 +6386,7 @@
                   <a:srgbClr val="1D1D1B"/>
                 </a:solidFill>
               </a:rPr>
-              <a:t>Route the revision and evidence—not just “please review”.</a:t>
+              <a:t>Give it a goal—not a script of prompts.</a:t>
             </a:r>
             <a:endParaRPr lang="en-US" sz="3000" dirty="0"/>
           </a:p>
@@ -6506,7 +6394,43 @@
       </p:sp>
       <p:sp>
         <p:nvSpPr>
-          <p:cNvPr id="5" name="Shape 2"/>
+          <p:cNvPr id="5" name="Text 2"/>
+          <p:cNvSpPr/>
+          <p:nvPr/>
+        </p:nvSpPr>
+        <p:spPr>
+          <a:xfrm>
+            <a:off x="640080" y="1901952"/>
+            <a:ext cx="10652760" cy="512064"/>
+          </a:xfrm>
+          <a:prstGeom prst="rect">
+            <a:avLst/>
+          </a:prstGeom>
+          <a:noFill/>
+          <a:ln/>
+        </p:spPr>
+        <p:txBody>
+          <a:bodyPr wrap="square" lIns="0" tIns="0" rIns="0" bIns="0" rtlCol="0" anchor="t"/>
+          <a:lstStyle/>
+          <a:p>
+            <a:pPr indent="0" marL="0">
+              <a:buNone/>
+            </a:pPr>
+            <a:r>
+              <a:rPr lang="en-US" sz="1500" dirty="0">
+                <a:solidFill>
+                  <a:srgbClr val="686761"/>
+                </a:solidFill>
+              </a:rPr>
+              <a:t>Use Session to work with AI. Use Work Center to delegate work to AI.</a:t>
+            </a:r>
+            <a:endParaRPr lang="en-US" sz="1500" dirty="0"/>
+          </a:p>
+        </p:txBody>
+      </p:sp>
+      <p:sp>
+        <p:nvSpPr>
+          <p:cNvPr id="6" name="Shape 3"/>
           <p:cNvSpPr/>
           <p:nvPr/>
         </p:nvSpPr>
@@ -6531,7 +6455,7 @@
       </p:sp>
       <p:sp>
         <p:nvSpPr>
-          <p:cNvPr id="6" name="Text 3"/>
+          <p:cNvPr id="7" name="Text 4"/>
           <p:cNvSpPr/>
           <p:nvPr/>
         </p:nvSpPr>
@@ -6559,7 +6483,7 @@
                   <a:srgbClr val="1D1D1B"/>
                 </a:solidFill>
               </a:rPr>
-              <a:t>IMPLEMENT</a:t>
+              <a:t>YOU DEFINE</a:t>
             </a:r>
             <a:endParaRPr lang="en-US" sz="2200" dirty="0"/>
           </a:p>
@@ -6567,7 +6491,7 @@
       </p:sp>
       <p:sp>
         <p:nvSpPr>
-          <p:cNvPr id="7" name="Text 4"/>
+          <p:cNvPr id="8" name="Text 5"/>
           <p:cNvSpPr/>
           <p:nvPr/>
         </p:nvSpPr>
@@ -6595,7 +6519,7 @@
                   <a:srgbClr val="686761"/>
                 </a:solidFill>
               </a:rPr>
-              <a:t>File + exact revision</a:t>
+              <a:t>Goal + constraints</a:t>
             </a:r>
             <a:endParaRPr lang="en-US" sz="1600" dirty="0"/>
           </a:p>
@@ -6609,7 +6533,7 @@
                   <a:srgbClr val="686761"/>
                 </a:solidFill>
               </a:rPr>
-              <a:t>Command + exit result</a:t>
+              <a:t>Working directory</a:t>
             </a:r>
             <a:endParaRPr lang="en-US" sz="1600" dirty="0"/>
           </a:p>
@@ -6623,7 +6547,7 @@
                   <a:srgbClr val="686761"/>
                 </a:solidFill>
               </a:rPr>
-              <a:t>Known limitations</a:t>
+              <a:t>Acceptance criteria</a:t>
             </a:r>
             <a:endParaRPr lang="en-US" sz="1600" dirty="0"/>
           </a:p>
@@ -6631,7 +6555,7 @@
       </p:sp>
       <p:sp>
         <p:nvSpPr>
-          <p:cNvPr id="8" name="Shape 5"/>
+          <p:cNvPr id="9" name="Shape 6"/>
           <p:cNvSpPr/>
           <p:nvPr/>
         </p:nvSpPr>
@@ -6655,7 +6579,7 @@
       </p:sp>
       <p:sp>
         <p:nvSpPr>
-          <p:cNvPr id="9" name="Shape 6"/>
+          <p:cNvPr id="10" name="Shape 7"/>
           <p:cNvSpPr/>
           <p:nvPr/>
         </p:nvSpPr>
@@ -6680,7 +6604,7 @@
       </p:sp>
       <p:sp>
         <p:nvSpPr>
-          <p:cNvPr id="10" name="Text 7"/>
+          <p:cNvPr id="11" name="Text 8"/>
           <p:cNvSpPr/>
           <p:nvPr/>
         </p:nvSpPr>
@@ -6708,7 +6632,7 @@
                   <a:srgbClr val="1D1D1B"/>
                 </a:solidFill>
               </a:rPr>
-              <a:t>REVIEW</a:t>
+              <a:t>AI EXECUTES</a:t>
             </a:r>
             <a:endParaRPr lang="en-US" sz="2200" dirty="0"/>
           </a:p>
@@ -6716,7 +6640,7 @@
       </p:sp>
       <p:sp>
         <p:nvSpPr>
-          <p:cNvPr id="11" name="Text 8"/>
+          <p:cNvPr id="12" name="Text 9"/>
           <p:cNvSpPr/>
           <p:nvPr/>
         </p:nvSpPr>
@@ -6744,7 +6668,7 @@
                   <a:srgbClr val="686761"/>
                 </a:solidFill>
               </a:rPr>
-              <a:t>Check the same revision.</a:t>
+              <a:t>Plan and assign work</a:t>
             </a:r>
             <a:endParaRPr lang="en-US" sz="1600" dirty="0"/>
           </a:p>
@@ -6758,7 +6682,7 @@
                   <a:srgbClr val="686761"/>
                 </a:solidFill>
               </a:rPr>
-              <a:t>Test the claim against</a:t>
+              <a:t>Run tools and checks</a:t>
             </a:r>
             <a:endParaRPr lang="en-US" sz="1600" dirty="0"/>
           </a:p>
@@ -6772,7 +6696,7 @@
                   <a:srgbClr val="686761"/>
                 </a:solidFill>
               </a:rPr>
-              <a:t>the acceptance criteria.</a:t>
+              <a:t>Record outcomes</a:t>
             </a:r>
             <a:endParaRPr lang="en-US" sz="1600" dirty="0"/>
           </a:p>
@@ -6780,7 +6704,7 @@
       </p:sp>
       <p:sp>
         <p:nvSpPr>
-          <p:cNvPr id="12" name="Shape 9"/>
+          <p:cNvPr id="13" name="Shape 10"/>
           <p:cNvSpPr/>
           <p:nvPr/>
         </p:nvSpPr>
@@ -6804,49 +6728,13 @@
       </p:sp>
       <p:sp>
         <p:nvSpPr>
-          <p:cNvPr id="13" name="Text 10"/>
-          <p:cNvSpPr/>
-          <p:nvPr/>
-        </p:nvSpPr>
-        <p:spPr>
-          <a:xfrm>
-            <a:off x="8247888" y="2953512"/>
-            <a:ext cx="1115568" cy="219456"/>
-          </a:xfrm>
-          <a:prstGeom prst="rect">
-            <a:avLst/>
-          </a:prstGeom>
-          <a:noFill/>
-          <a:ln/>
-        </p:spPr>
-        <p:txBody>
-          <a:bodyPr wrap="square" lIns="0" tIns="0" rIns="0" bIns="0" rtlCol="0" anchor="ctr"/>
-          <a:lstStyle/>
-          <a:p>
-            <a:pPr indent="0" marL="0">
-              <a:buNone/>
-            </a:pPr>
-            <a:r>
-              <a:rPr lang="en-US" sz="1100" b="1" dirty="0">
-                <a:solidFill>
-                  <a:srgbClr val="8B5E3C"/>
-                </a:solidFill>
-              </a:rPr>
-              <a:t>APPROVE</a:t>
-            </a:r>
-            <a:endParaRPr lang="en-US" sz="1100" dirty="0"/>
-          </a:p>
-        </p:txBody>
-      </p:sp>
-      <p:sp>
-        <p:nvSpPr>
           <p:cNvPr id="14" name="Text 11"/>
           <p:cNvSpPr/>
           <p:nvPr/>
         </p:nvSpPr>
         <p:spPr>
           <a:xfrm>
-            <a:off x="9381744" y="3310128"/>
+            <a:off x="9381744" y="2999232"/>
             <a:ext cx="2103120" cy="384048"/>
           </a:xfrm>
           <a:prstGeom prst="rect">
@@ -6863,14 +6751,14 @@
               <a:buNone/>
             </a:pPr>
             <a:r>
-              <a:rPr lang="en-US" sz="2300" b="1" dirty="0">
+              <a:rPr lang="en-US" sz="2200" b="1" dirty="0">
                 <a:solidFill>
                   <a:srgbClr val="1D1D1B"/>
                 </a:solidFill>
               </a:rPr>
-              <a:t>DELIVER</a:t>
-            </a:r>
-            <a:endParaRPr lang="en-US" sz="2300" dirty="0"/>
+              <a:t>YOU CHECK</a:t>
+            </a:r>
+            <a:endParaRPr lang="en-US" sz="2200" dirty="0"/>
           </a:p>
         </p:txBody>
       </p:sp>
@@ -6882,8 +6770,8 @@
         </p:nvSpPr>
         <p:spPr>
           <a:xfrm>
-            <a:off x="9381744" y="3840480"/>
-            <a:ext cx="2075688" cy="594360"/>
+            <a:off x="9381744" y="3575304"/>
+            <a:ext cx="2103120" cy="1005840"/>
           </a:xfrm>
           <a:prstGeom prst="rect">
             <a:avLst/>
@@ -6899,14 +6787,42 @@
               <a:buNone/>
             </a:pPr>
             <a:r>
-              <a:rPr lang="en-US" sz="1500" dirty="0">
+              <a:rPr lang="en-US" sz="1600" dirty="0">
                 <a:solidFill>
                   <a:srgbClr val="686761"/>
                 </a:solidFill>
               </a:rPr>
-              <a:t>Only the reviewed result</a:t>
-            </a:r>
-            <a:endParaRPr lang="en-US" sz="1500" dirty="0"/>
+              <a:t>Result + evidence</a:t>
+            </a:r>
+            <a:endParaRPr lang="en-US" sz="1600" dirty="0"/>
+          </a:p>
+          <a:p>
+            <a:pPr indent="0" marL="0">
+              <a:buNone/>
+            </a:pPr>
+            <a:r>
+              <a:rPr lang="en-US" sz="1600" dirty="0">
+                <a:solidFill>
+                  <a:srgbClr val="686761"/>
+                </a:solidFill>
+              </a:rPr>
+              <a:t>Or a specific decision</a:t>
+            </a:r>
+            <a:endParaRPr lang="en-US" sz="1600" dirty="0"/>
+          </a:p>
+          <a:p>
+            <a:pPr indent="0" marL="0">
+              <a:buNone/>
+            </a:pPr>
+            <a:r>
+              <a:rPr lang="en-US" sz="1600" dirty="0">
+                <a:solidFill>
+                  <a:srgbClr val="686761"/>
+                </a:solidFill>
+              </a:rPr>
+              <a:t>that needs your input</a:t>
+            </a:r>
+            <a:endParaRPr lang="en-US" sz="1600" dirty="0"/>
           </a:p>
         </p:txBody>
       </p:sp>
@@ -6918,8 +6834,8 @@
         </p:nvSpPr>
         <p:spPr>
           <a:xfrm>
-            <a:off x="2231136" y="5257800"/>
-            <a:ext cx="4297680" cy="0"/>
+            <a:off x="731520" y="5431536"/>
+            <a:ext cx="10698480" cy="0"/>
           </a:xfrm>
           <a:prstGeom prst="line">
             <a:avLst/>
@@ -6930,7 +6846,6 @@
               <a:srgbClr val="8B5E3C"/>
             </a:solidFill>
             <a:prstDash val="solid"/>
-            <a:headEnd type="triangle"/>
           </a:ln>
         </p:spPr>
       </p:sp>
@@ -6942,31 +6857,31 @@
         </p:nvSpPr>
         <p:spPr>
           <a:xfrm>
-            <a:off x="2286000" y="5504688"/>
-            <a:ext cx="6035040" cy="274320"/>
-          </a:xfrm>
-          <a:prstGeom prst="rect">
-            <a:avLst/>
-          </a:prstGeom>
-          <a:noFill/>
-          <a:ln/>
-        </p:spPr>
-        <p:txBody>
-          <a:bodyPr wrap="square" lIns="0" tIns="0" rIns="0" bIns="0" rtlCol="0" anchor="ctr"/>
-          <a:lstStyle/>
-          <a:p>
-            <a:pPr indent="0" marL="0">
-              <a:buNone/>
-            </a:pPr>
-            <a:r>
-              <a:rPr lang="en-US" sz="1300" b="1" dirty="0">
+            <a:off x="731520" y="5760720"/>
+            <a:ext cx="10698480" cy="438912"/>
+          </a:xfrm>
+          <a:prstGeom prst="rect">
+            <a:avLst/>
+          </a:prstGeom>
+          <a:noFill/>
+          <a:ln/>
+        </p:spPr>
+        <p:txBody>
+          <a:bodyPr wrap="square" lIns="0" tIns="0" rIns="0" bIns="0" rtlCol="0" anchor="ctr"/>
+          <a:lstStyle/>
+          <a:p>
+            <a:pPr indent="0" marL="0">
+              <a:buNone/>
+            </a:pPr>
+            <a:r>
+              <a:rPr lang="en-US" sz="1900" dirty="0">
                 <a:solidFill>
                   <a:srgbClr val="8B5E3C"/>
                 </a:solidFill>
               </a:rPr>
-              <a:t>BLOCKER → CORRECT THE WORK → REVIEW AGAIN</a:t>
-            </a:r>
-            <a:endParaRPr lang="en-US" sz="1300" dirty="0"/>
+              <a:t>Less turn-by-turn supervision. A persistent goal with visible execution.</a:t>
+            </a:r>
+            <a:endParaRPr lang="en-US" sz="1900" dirty="0"/>
           </a:p>
         </p:txBody>
       </p:sp>
@@ -7070,7 +6985,7 @@
                   <a:srgbClr val="8B5E3C"/>
                 </a:solidFill>
               </a:rPr>
-              <a:t>05 / INSPECT THE WORKSPACE</a:t>
+              <a:t>REAL TOOLS. VISIBLE WORK.</a:t>
             </a:r>
             <a:endParaRPr lang="en-US" sz="1100" dirty="0"/>
           </a:p>
@@ -7106,7 +7021,7 @@
                   <a:srgbClr val="1D1D1B"/>
                 </a:solidFill>
               </a:rPr>
-              <a:t>Open the source. Read the command and its result.</a:t>
+              <a:t>More than a chat window: a working environment.</a:t>
             </a:r>
             <a:endParaRPr lang="en-US" sz="3000" dirty="0"/>
           </a:p>
@@ -7142,7 +7057,7 @@
                   <a:srgbClr val="1D1D1B"/>
                 </a:solidFill>
               </a:rPr>
-              <a:t>FILES / agent/yeaft/session.js</a:t>
+              <a:t>FILES / inspect the actual source</a:t>
             </a:r>
             <a:endParaRPr lang="en-US" sz="1600" dirty="0"/>
           </a:p>
@@ -7178,7 +7093,7 @@
                   <a:srgbClr val="1D1D1B"/>
                 </a:solidFill>
               </a:rPr>
-              <a:t>TERMINAL / syntax check</a:t>
+              <a:t>TERMINAL / inspect command output</a:t>
             </a:r>
             <a:endParaRPr lang="en-US" sz="1600" dirty="0"/>
           </a:p>
@@ -7186,7 +7101,7 @@
       </p:sp>
       <p:pic>
         <p:nvPicPr>
-          <p:cNvPr id="7" name="Image 0" descr="/home/azureuser/projects/yeaft-web-code-agent/.yeaft/worktrees/showcase-story-visual-refresh/artifacts/showcase/assets/08-workbench-files-correct.png">    </p:cNvPr>
+          <p:cNvPr id="7" name="Image 0" descr="/home/azureuser/projects/yeaft-web-code-agent/.yeaft/worktrees/showcase-task-first/artifacts/showcase/assets/08-workbench-files-correct.png">    </p:cNvPr>
           <p:cNvPicPr>
             <a:picLocks noChangeAspect="1"/>
           </p:cNvPicPr>
@@ -7210,7 +7125,7 @@
       </p:pic>
       <p:pic>
         <p:nvPicPr>
-          <p:cNvPr id="8" name="Image 1" descr="/home/azureuser/projects/yeaft-web-code-agent/.yeaft/worktrees/showcase-story-visual-refresh/artifacts/showcase/assets/08-workbench-terminal-correct.png">    </p:cNvPr>
+          <p:cNvPr id="8" name="Image 1" descr="/home/azureuser/projects/yeaft-web-code-agent/.yeaft/worktrees/showcase-task-first/artifacts/showcase/assets/08-workbench-terminal-correct.png">    </p:cNvPr>
           <p:cNvPicPr>
             <a:picLocks noChangeAspect="1"/>
           </p:cNvPicPr>
@@ -7262,7 +7177,7 @@
                   <a:srgbClr val="686761"/>
                 </a:solidFill>
               </a:rPr>
-              <a:t>Visible path + real source</a:t>
+              <a:t>Stay close to the files the Agent works with.</a:t>
             </a:r>
             <a:endParaRPr lang="en-US" sz="1400" dirty="0"/>
           </a:p>
@@ -7298,7 +7213,7 @@
                   <a:srgbClr val="8B5E3C"/>
                 </a:solidFill>
               </a:rPr>
-              <a:t>node --check ≠ a behavioral test</a:t>
+              <a:t>Example: node --check, not a full test suite.</a:t>
             </a:r>
             <a:endParaRPr lang="en-US" sz="1400" dirty="0"/>
           </a:p>
@@ -7440,7 +7355,7 @@
                   <a:srgbClr val="8B5E3C"/>
                 </a:solidFill>
               </a:rPr>
-              <a:t>06 / PRESERVE LONGER WORK · PREVIEW</a:t>
+              <a:t>WORK CENTER · PREVIEW</a:t>
             </a:r>
             <a:endParaRPr lang="en-US" sz="1100" dirty="0"/>
           </a:p>
@@ -7476,7 +7391,7 @@
                   <a:srgbClr val="1D1D1B"/>
                 </a:solidFill>
               </a:rPr>
-              <a:t>When the goal outlasts a conversation, record it as work.</a:t>
+              <a:t>The task persists beyond the conversation.</a:t>
             </a:r>
             <a:endParaRPr lang="en-US" sz="3000" dirty="0"/>
           </a:p>
@@ -7484,7 +7399,7 @@
       </p:sp>
       <p:pic>
         <p:nvPicPr>
-          <p:cNvPr id="5" name="Image 0" descr="/home/azureuser/projects/yeaft-web-code-agent/.yeaft/worktrees/showcase-story-visual-refresh/artifacts/showcase/assets/09-work-center-structure.png">    </p:cNvPr>
+          <p:cNvPr id="5" name="Image 0" descr="/home/azureuser/projects/yeaft-web-code-agent/.yeaft/worktrees/showcase-task-first/artifacts/showcase/assets/09-work-center-structure.png">    </p:cNvPr>
           <p:cNvPicPr>
             <a:picLocks noChangeAspect="1"/>
           </p:cNvPicPr>
@@ -7536,7 +7451,7 @@
                   <a:srgbClr val="8B5E3C"/>
                 </a:solidFill>
               </a:rPr>
-              <a:t>WORKITEM</a:t>
+              <a:t>KEEP THE GOAL</a:t>
             </a:r>
             <a:endParaRPr lang="en-US" sz="1300" dirty="0"/>
           </a:p>
@@ -7551,7 +7466,7 @@
         <p:spPr>
           <a:xfrm>
             <a:off x="8366760" y="3017520"/>
-            <a:ext cx="2971800" cy="594360"/>
+            <a:ext cx="2971800" cy="667512"/>
           </a:xfrm>
           <a:prstGeom prst="rect">
             <a:avLst/>
@@ -7572,7 +7487,7 @@
                   <a:srgbClr val="686761"/>
                 </a:solidFill>
               </a:rPr>
-              <a:t>The goal and acceptance criteria</a:t>
+              <a:t>WorkItem: objective and acceptance criteria</a:t>
             </a:r>
             <a:endParaRPr lang="en-US" sz="1800" dirty="0"/>
           </a:p>
@@ -7608,7 +7523,7 @@
                   <a:srgbClr val="8B5E3C"/>
                 </a:solidFill>
               </a:rPr>
-              <a:t>ACTION</a:t>
+              <a:t>FOLLOW THE WORK</a:t>
             </a:r>
             <a:endParaRPr lang="en-US" sz="1300" dirty="0"/>
           </a:p>
@@ -7623,7 +7538,7 @@
         <p:spPr>
           <a:xfrm>
             <a:off x="8366760" y="4133088"/>
-            <a:ext cx="2971800" cy="594360"/>
+            <a:ext cx="2971800" cy="667512"/>
           </a:xfrm>
           <a:prstGeom prst="rect">
             <a:avLst/>
@@ -7644,7 +7559,7 @@
                   <a:srgbClr val="686761"/>
                 </a:solidFill>
               </a:rPr>
-              <a:t>A concrete unit of work</a:t>
+              <a:t>Action: assigned work and current status</a:t>
             </a:r>
             <a:endParaRPr lang="en-US" sz="1800" dirty="0"/>
           </a:p>
@@ -7680,7 +7595,7 @@
                   <a:srgbClr val="8B5E3C"/>
                 </a:solidFill>
               </a:rPr>
-              <a:t>RUN</a:t>
+              <a:t>INSPECT THE RESULT</a:t>
             </a:r>
             <a:endParaRPr lang="en-US" sz="1300" dirty="0"/>
           </a:p>
@@ -7695,7 +7610,7 @@
         <p:spPr>
           <a:xfrm>
             <a:off x="8366760" y="5248656"/>
-            <a:ext cx="2971800" cy="594360"/>
+            <a:ext cx="2971800" cy="667512"/>
           </a:xfrm>
           <a:prstGeom prst="rect">
             <a:avLst/>
@@ -7716,7 +7631,7 @@
                   <a:srgbClr val="686761"/>
                 </a:solidFill>
               </a:rPr>
-              <a:t>One execution attempt and result</a:t>
+              <a:t>Run: execution attempts and evidence</a:t>
             </a:r>
             <a:endParaRPr lang="en-US" sz="1800" dirty="0"/>
           </a:p>
@@ -7752,7 +7667,7 @@
                   <a:srgbClr val="686761"/>
                 </a:solidFill>
               </a:rPr>
-              <a:t>Real Yeaft UI · Staged inspection demo · Separate from Session history</a:t>
+              <a:t>Real Yeaft UI · Staged inspection demo · Agent-side execution · Separate from Session</a:t>
             </a:r>
             <a:endParaRPr lang="en-US" sz="1000" dirty="0"/>
           </a:p>

</xml_diff>